<commit_message>
Update project presentation to elegant white theme with slide transitions and images
</commit_message>
<xml_diff>
--- a/documentation/SentinelMRO_Project_Presentation.pptx
+++ b/documentation/SentinelMRO_Project_Presentation.pptx
@@ -3092,7 +3092,7 @@
     <p:bg>
       <p:bgPr>
         <a:solidFill>
-          <a:srgbClr val="0A0A0C"/>
+          <a:srgbClr val="FAFAFA"/>
         </a:solidFill>
         <a:effectLst/>
       </p:bgPr>
@@ -3112,14 +3112,14 @@
         </p:nvSpPr>
         <p:spPr>
           <a:xfrm>
-            <a:off x="457200" y="1371600"/>
-            <a:ext cx="91440" cy="2011680"/>
+            <a:off x="548640" y="1280160"/>
+            <a:ext cx="73152" cy="2011680"/>
           </a:xfrm>
           <a:prstGeom prst="rect">
             <a:avLst/>
           </a:prstGeom>
           <a:solidFill>
-            <a:srgbClr val="6366F1"/>
+            <a:srgbClr val="1E3A8A"/>
           </a:solidFill>
           <a:ln>
             <a:noFill/>
@@ -3155,8 +3155,8 @@
         </p:nvSpPr>
         <p:spPr>
           <a:xfrm>
-            <a:off x="731520" y="1280160"/>
-            <a:ext cx="7772400" cy="1097280"/>
+            <a:off x="822960" y="1188720"/>
+            <a:ext cx="7772400" cy="1280160"/>
           </a:xfrm>
           <a:prstGeom prst="rect">
             <a:avLst/>
@@ -3170,9 +3170,9 @@
           <a:lstStyle/>
           <a:p>
             <a:pPr>
-              <a:defRPr sz="4400" b="1">
-                <a:solidFill>
-                  <a:srgbClr val="FFFFFF"/>
+              <a:defRPr sz="4600" b="1">
+                <a:solidFill>
+                  <a:srgbClr val="1E3A8A"/>
                 </a:solidFill>
                 <a:latin typeface="Arial"/>
               </a:defRPr>
@@ -3184,11 +3184,11 @@
           <a:p>
             <a:pPr>
               <a:spcBef>
-                <a:spcPts val="800"/>
+                <a:spcPts val="600"/>
               </a:spcBef>
-              <a:defRPr sz="1600">
-                <a:solidFill>
-                  <a:srgbClr val="14B8A6"/>
+              <a:defRPr sz="1550">
+                <a:solidFill>
+                  <a:srgbClr val="0D9488"/>
                 </a:solidFill>
                 <a:latin typeface="Arial"/>
               </a:defRPr>
@@ -3207,7 +3207,7 @@
         </p:nvSpPr>
         <p:spPr>
           <a:xfrm>
-            <a:off x="731520" y="3474720"/>
+            <a:off x="822960" y="3474720"/>
             <a:ext cx="7315200" cy="1097280"/>
           </a:xfrm>
           <a:prstGeom prst="rect">
@@ -3224,7 +3224,7 @@
             <a:pPr>
               <a:defRPr sz="1100" b="1">
                 <a:solidFill>
-                  <a:srgbClr val="9CA3AF"/>
+                  <a:srgbClr val="6B7280"/>
                 </a:solidFill>
               </a:defRPr>
             </a:pPr>
@@ -3239,12 +3239,12 @@
               </a:spcBef>
               <a:defRPr sz="950">
                 <a:solidFill>
-                  <a:srgbClr val="6B7280"/>
+                  <a:srgbClr val="9CA3AF"/>
                 </a:solidFill>
               </a:defRPr>
             </a:pPr>
             <a:r>
-              <a:t>Backend: Python, PyTorch, ONNX INT8 Quantization, SQLite | Frontend: Next.js 15 App Router</a:t>
+              <a:t>Decentralized Prognostics | SQLite Merkle Mountain Range Ledger | Next.js 15 Command Dashboard</a:t>
             </a:r>
           </a:p>
         </p:txBody>
@@ -3254,6 +3254,9 @@
   <p:clrMapOvr>
     <a:masterClrMapping/>
   </p:clrMapOvr>
+  <p:transition spd="med">
+    <p:fade/>
+  </p:transition>
 </p:sld>
 </file>
 
@@ -3263,7 +3266,7 @@
     <p:bg>
       <p:bgPr>
         <a:solidFill>
-          <a:srgbClr val="0A0A0C"/>
+          <a:srgbClr val="FAFAFA"/>
         </a:solidFill>
         <a:effectLst/>
       </p:bgPr>
@@ -3284,17 +3287,17 @@
         <p:spPr>
           <a:xfrm>
             <a:off x="0" y="0"/>
-            <a:ext cx="9144000" cy="914400"/>
+            <a:ext cx="9144000" cy="822960"/>
           </a:xfrm>
           <a:prstGeom prst="rect">
             <a:avLst/>
           </a:prstGeom>
           <a:solidFill>
-            <a:srgbClr val="111827"/>
+            <a:srgbClr val="F3F4F6"/>
           </a:solidFill>
-          <a:ln w="19050">
+          <a:ln w="12700">
             <a:solidFill>
-              <a:srgbClr val="6366F1"/>
+              <a:srgbClr val="E5E7EB"/>
             </a:solidFill>
           </a:ln>
         </p:spPr>
@@ -3328,8 +3331,8 @@
         </p:nvSpPr>
         <p:spPr>
           <a:xfrm>
-            <a:off x="457200" y="137160"/>
-            <a:ext cx="5943600" cy="640080"/>
+            <a:off x="457200" y="109728"/>
+            <a:ext cx="5943600" cy="548640"/>
           </a:xfrm>
           <a:prstGeom prst="rect">
             <a:avLst/>
@@ -3343,9 +3346,9 @@
           <a:lstStyle/>
           <a:p>
             <a:pPr>
-              <a:defRPr sz="2200" b="1">
-                <a:solidFill>
-                  <a:srgbClr val="FFFFFF"/>
+              <a:defRPr sz="2000" b="1">
+                <a:solidFill>
+                  <a:srgbClr val="1E3A8A"/>
                 </a:solidFill>
                 <a:latin typeface="Arial"/>
               </a:defRPr>
@@ -3364,7 +3367,7 @@
         </p:nvSpPr>
         <p:spPr>
           <a:xfrm>
-            <a:off x="6400800" y="274320"/>
+            <a:off x="6400800" y="228600"/>
             <a:ext cx="2286000" cy="365760"/>
           </a:xfrm>
           <a:prstGeom prst="rect">
@@ -3379,9 +3382,9 @@
           <a:lstStyle/>
           <a:p>
             <a:pPr algn="r">
-              <a:defRPr sz="1000" b="1">
-                <a:solidFill>
-                  <a:srgbClr val="818CF8"/>
+              <a:defRPr sz="950" b="1">
+                <a:solidFill>
+                  <a:srgbClr val="0D9488"/>
                 </a:solidFill>
                 <a:latin typeface="Arial"/>
               </a:defRPr>
@@ -3394,226 +3397,24 @@
       </p:sp>
       <p:sp>
         <p:nvSpPr>
-          <p:cNvPr id="5" name="TextBox 4"/>
-          <p:cNvSpPr txBox="1"/>
-          <p:nvPr/>
-        </p:nvSpPr>
-        <p:spPr>
-          <a:xfrm>
-            <a:off x="457200" y="1188720"/>
-            <a:ext cx="3931920" cy="3474720"/>
-          </a:xfrm>
-          <a:prstGeom prst="rect">
-            <a:avLst/>
-          </a:prstGeom>
-          <a:noFill/>
-        </p:spPr>
-        <p:txBody>
-          <a:bodyPr wrap="square" lIns="0" rIns="0" tIns="0" bIns="0">
-            <a:spAutoFit/>
-          </a:bodyPr>
-          <a:lstStyle/>
-          <a:p>
-            <a:pPr>
-              <a:spcAft>
-                <a:spcPts val="1000"/>
-              </a:spcAft>
-              <a:defRPr sz="1500" b="1">
-                <a:solidFill>
-                  <a:srgbClr val="14B8A6"/>
-                </a:solidFill>
-              </a:defRPr>
-            </a:pPr>
-            <a:r>
-              <a:t>Legacy Architecture Bottlenecks</a:t>
-            </a:r>
-          </a:p>
-          <a:p>
-            <a:pPr>
-              <a:spcAft>
-                <a:spcPts val="800"/>
-              </a:spcAft>
-            </a:pPr>
-            <a:r>
-              <a:rPr b="1" sz="1300">
-                <a:solidFill>
-                  <a:srgbClr val="FFFFFF"/>
-                </a:solidFill>
-                <a:latin typeface="Arial"/>
-              </a:rPr>
-              <a:t>• Bandwidth &amp; Latency: </a:t>
-            </a:r>
-            <a:r>
-              <a:rPr sz="1200">
-                <a:solidFill>
-                  <a:srgbClr val="D1D5DB"/>
-                </a:solidFill>
-                <a:latin typeface="Arial"/>
-              </a:rPr>
-              <a:t>Uploading gigabytes of high-frequency sensor telemetry to clouds causes latency and increases network overhead.</a:t>
-            </a:r>
-          </a:p>
-          <a:p>
-            <a:pPr>
-              <a:spcAft>
-                <a:spcPts val="800"/>
-              </a:spcAft>
-            </a:pPr>
-            <a:r>
-              <a:rPr b="1" sz="1300">
-                <a:solidFill>
-                  <a:srgbClr val="FFFFFF"/>
-                </a:solidFill>
-                <a:latin typeface="Arial"/>
-              </a:rPr>
-              <a:t>• Proprietary Data Leakage: </a:t>
-            </a:r>
-            <a:r>
-              <a:rPr sz="1200">
-                <a:solidFill>
-                  <a:srgbClr val="D1D5DB"/>
-                </a:solidFill>
-                <a:latin typeface="Arial"/>
-              </a:rPr>
-              <a:t>Airlines are highly protective of engine metrics; central uploading raises severe data security concerns.</a:t>
-            </a:r>
-          </a:p>
-        </p:txBody>
-      </p:sp>
-      <p:sp>
-        <p:nvSpPr>
-          <p:cNvPr id="6" name="TextBox 5"/>
-          <p:cNvSpPr txBox="1"/>
-          <p:nvPr/>
-        </p:nvSpPr>
-        <p:spPr>
-          <a:xfrm>
-            <a:off x="4754880" y="1188720"/>
-            <a:ext cx="3931920" cy="3474720"/>
-          </a:xfrm>
-          <a:prstGeom prst="rect">
-            <a:avLst/>
-          </a:prstGeom>
-          <a:noFill/>
-        </p:spPr>
-        <p:txBody>
-          <a:bodyPr wrap="square" lIns="0" rIns="0" tIns="0" bIns="0">
-            <a:spAutoFit/>
-          </a:bodyPr>
-          <a:lstStyle/>
-          <a:p>
-            <a:pPr>
-              <a:spcAft>
-                <a:spcPts val="1000"/>
-              </a:spcAft>
-              <a:defRPr sz="1500" b="1">
-                <a:solidFill>
-                  <a:srgbClr val="14B8A6"/>
-                </a:solidFill>
-              </a:defRPr>
-            </a:pPr>
-            <a:r>
-              <a:t>Audit &amp; Database Vulnerabilities</a:t>
-            </a:r>
-          </a:p>
-          <a:p>
-            <a:pPr>
-              <a:spcAft>
-                <a:spcPts val="800"/>
-              </a:spcAft>
-            </a:pPr>
-            <a:r>
-              <a:rPr b="1" sz="1300">
-                <a:solidFill>
-                  <a:srgbClr val="FFFFFF"/>
-                </a:solidFill>
-                <a:latin typeface="Arial"/>
-              </a:rPr>
-              <a:t>• Retroactive Manipulation: </a:t>
-            </a:r>
-            <a:r>
-              <a:rPr sz="1200">
-                <a:solidFill>
-                  <a:srgbClr val="D1D5DB"/>
-                </a:solidFill>
-                <a:latin typeface="Arial"/>
-              </a:rPr>
-              <a:t>Standard maintenance logs stored in centralized databases lack cryptographic seals, risking unauthorized tampering.</a:t>
-            </a:r>
-          </a:p>
-          <a:p>
-            <a:pPr>
-              <a:spcAft>
-                <a:spcPts val="800"/>
-              </a:spcAft>
-            </a:pPr>
-            <a:r>
-              <a:rPr b="1" sz="1300">
-                <a:solidFill>
-                  <a:srgbClr val="FFFFFF"/>
-                </a:solidFill>
-                <a:latin typeface="Arial"/>
-              </a:rPr>
-              <a:t>• Non-IID Divergence: </a:t>
-            </a:r>
-            <a:r>
-              <a:rPr sz="1200">
-                <a:solidFill>
-                  <a:srgbClr val="D1D5DB"/>
-                </a:solidFill>
-                <a:latin typeface="Arial"/>
-              </a:rPr>
-              <a:t>Operating profiles vary across MRO stations. Centralized models become biased toward nominal or high-use fleets.</a:t>
-            </a:r>
-          </a:p>
-        </p:txBody>
-      </p:sp>
-    </p:spTree>
-  </p:cSld>
-  <p:clrMapOvr>
-    <a:masterClrMapping/>
-  </p:clrMapOvr>
-</p:sld>
-</file>
-
-<file path=ppt/slides/slide3.xml><?xml version="1.0" encoding="utf-8"?>
-<p:sld xmlns:a="http://schemas.openxmlformats.org/drawingml/2006/main" xmlns:p="http://schemas.openxmlformats.org/presentationml/2006/main" xmlns:r="http://schemas.openxmlformats.org/officeDocument/2006/relationships">
-  <p:cSld>
-    <p:bg>
-      <p:bgPr>
-        <a:solidFill>
-          <a:srgbClr val="0A0A0C"/>
-        </a:solidFill>
-        <a:effectLst/>
-      </p:bgPr>
-    </p:bg>
-    <p:spTree>
-      <p:nvGrpSpPr>
-        <p:cNvPr id="1" name=""/>
-        <p:cNvGrpSpPr/>
-        <p:nvPr/>
-      </p:nvGrpSpPr>
-      <p:grpSpPr/>
-      <p:sp>
-        <p:nvSpPr>
-          <p:cNvPr id="2" name="Rectangle 1"/>
+          <p:cNvPr id="5" name="Rectangle 4"/>
           <p:cNvSpPr/>
           <p:nvPr/>
         </p:nvSpPr>
         <p:spPr>
           <a:xfrm>
-            <a:off x="0" y="0"/>
-            <a:ext cx="9144000" cy="914400"/>
+            <a:off x="457200" y="1188720"/>
+            <a:ext cx="3931920" cy="3383280"/>
           </a:xfrm>
           <a:prstGeom prst="rect">
             <a:avLst/>
           </a:prstGeom>
           <a:solidFill>
-            <a:srgbClr val="111827"/>
+            <a:srgbClr val="F3F4F6"/>
           </a:solidFill>
-          <a:ln w="19050">
+          <a:ln>
             <a:solidFill>
-              <a:srgbClr val="6366F1"/>
+              <a:srgbClr val="E5E7EB"/>
             </a:solidFill>
           </a:ln>
         </p:spPr>
@@ -3632,105 +3433,101 @@
           </a:fontRef>
         </p:style>
         <p:txBody>
-          <a:bodyPr rtlCol="0" anchor="ctr"/>
-          <a:lstStyle/>
-          <a:p>
-            <a:pPr algn="ctr"/>
-          </a:p>
-        </p:txBody>
-      </p:sp>
-      <p:sp>
-        <p:nvSpPr>
-          <p:cNvPr id="3" name="TextBox 2"/>
-          <p:cNvSpPr txBox="1"/>
-          <p:nvPr/>
-        </p:nvSpPr>
-        <p:spPr>
-          <a:xfrm>
-            <a:off x="457200" y="137160"/>
-            <a:ext cx="5943600" cy="640080"/>
-          </a:xfrm>
-          <a:prstGeom prst="rect">
-            <a:avLst/>
-          </a:prstGeom>
-          <a:noFill/>
-        </p:spPr>
-        <p:txBody>
-          <a:bodyPr wrap="square" lIns="0" rIns="0" tIns="0" bIns="0">
-            <a:spAutoFit/>
-          </a:bodyPr>
-          <a:lstStyle/>
-          <a:p>
-            <a:pPr>
-              <a:defRPr sz="2200" b="1">
-                <a:solidFill>
-                  <a:srgbClr val="FFFFFF"/>
-                </a:solidFill>
-                <a:latin typeface="Arial"/>
+          <a:bodyPr rtlCol="0" anchor="ctr" wrap="square" lIns="137160" rIns="137160" tIns="137160"/>
+          <a:lstStyle/>
+          <a:p>
+            <a:pPr algn="ctr">
+              <a:spcAft>
+                <a:spcPts val="800"/>
+              </a:spcAft>
+              <a:defRPr sz="1500" b="1">
+                <a:solidFill>
+                  <a:srgbClr val="1E3A8A"/>
+                </a:solidFill>
               </a:defRPr>
             </a:pPr>
             <a:r>
-              <a:t>The Solution: SentinelMRO Architecture</a:t>
-            </a:r>
-          </a:p>
-        </p:txBody>
-      </p:sp>
-      <p:sp>
-        <p:nvSpPr>
-          <p:cNvPr id="4" name="TextBox 3"/>
-          <p:cNvSpPr txBox="1"/>
-          <p:nvPr/>
-        </p:nvSpPr>
-        <p:spPr>
-          <a:xfrm>
-            <a:off x="6400800" y="274320"/>
-            <a:ext cx="2286000" cy="365760"/>
-          </a:xfrm>
-          <a:prstGeom prst="rect">
-            <a:avLst/>
-          </a:prstGeom>
-          <a:noFill/>
-        </p:spPr>
-        <p:txBody>
-          <a:bodyPr wrap="square" lIns="0" rIns="0" tIns="0" bIns="0">
-            <a:spAutoFit/>
-          </a:bodyPr>
-          <a:lstStyle/>
-          <a:p>
-            <a:pPr algn="r">
-              <a:defRPr sz="1000" b="1">
-                <a:solidFill>
-                  <a:srgbClr val="818CF8"/>
-                </a:solidFill>
-                <a:latin typeface="Arial"/>
-              </a:defRPr>
+              <a:t>Legacy Architecture Bottlenecks</a:t>
+            </a:r>
+          </a:p>
+          <a:p>
+            <a:pPr>
+              <a:spcBef>
+                <a:spcPts val="400"/>
+              </a:spcBef>
+              <a:spcAft>
+                <a:spcPts val="800"/>
+              </a:spcAft>
             </a:pPr>
             <a:r>
-              <a:t>Subsystem Overview</a:t>
-            </a:r>
-          </a:p>
-        </p:txBody>
-      </p:sp>
-      <p:sp>
-        <p:nvSpPr>
-          <p:cNvPr id="5" name="Rectangle 4"/>
+              <a:rPr b="1" sz="1200">
+                <a:solidFill>
+                  <a:srgbClr val="1F2937"/>
+                </a:solidFill>
+                <a:latin typeface="Arial"/>
+              </a:rPr>
+              <a:t>• Bandwidth &amp; Latency: </a:t>
+            </a:r>
+            <a:r>
+              <a:rPr sz="1100">
+                <a:solidFill>
+                  <a:srgbClr val="4B5563"/>
+                </a:solidFill>
+                <a:latin typeface="Arial"/>
+              </a:rPr>
+              <a:t>Uploading gigabytes of high-frequency telemetry streams to clouds causes latency and increases network overhead.</a:t>
+            </a:r>
+          </a:p>
+          <a:p>
+            <a:pPr>
+              <a:spcBef>
+                <a:spcPts val="400"/>
+              </a:spcBef>
+              <a:spcAft>
+                <a:spcPts val="800"/>
+              </a:spcAft>
+            </a:pPr>
+            <a:r>
+              <a:rPr b="1" sz="1200">
+                <a:solidFill>
+                  <a:srgbClr val="1F2937"/>
+                </a:solidFill>
+                <a:latin typeface="Arial"/>
+              </a:rPr>
+              <a:t>• Airline Data Privacy: </a:t>
+            </a:r>
+            <a:r>
+              <a:rPr sz="1100">
+                <a:solidFill>
+                  <a:srgbClr val="4B5563"/>
+                </a:solidFill>
+                <a:latin typeface="Arial"/>
+              </a:rPr>
+              <a:t>Airlines are highly protective of operational metrics; central uploading raises severe data security concerns.</a:t>
+            </a:r>
+          </a:p>
+        </p:txBody>
+      </p:sp>
+      <p:sp>
+        <p:nvSpPr>
+          <p:cNvPr id="6" name="Rectangle 5"/>
           <p:cNvSpPr/>
           <p:nvPr/>
         </p:nvSpPr>
         <p:spPr>
           <a:xfrm>
-            <a:off x="457200" y="1280160"/>
-            <a:ext cx="2560320" cy="3291840"/>
+            <a:off x="4754880" y="1188720"/>
+            <a:ext cx="3931920" cy="3383280"/>
           </a:xfrm>
           <a:prstGeom prst="rect">
             <a:avLst/>
           </a:prstGeom>
           <a:solidFill>
-            <a:srgbClr val="111827"/>
+            <a:srgbClr val="F3F4F6"/>
           </a:solidFill>
-          <a:ln w="12700">
+          <a:ln>
             <a:solidFill>
-              <a:srgbClr val="6366F1"/>
+              <a:srgbClr val="E5E7EB"/>
             </a:solidFill>
           </a:ln>
         </p:spPr>
@@ -3754,52 +3551,125 @@
           <a:p>
             <a:pPr algn="ctr">
               <a:spcAft>
-                <a:spcPts val="1000"/>
+                <a:spcPts val="800"/>
               </a:spcAft>
-              <a:defRPr sz="1400" b="1">
-                <a:solidFill>
-                  <a:srgbClr val="14B8A6"/>
+              <a:defRPr sz="1500" b="1">
+                <a:solidFill>
+                  <a:srgbClr val="1E3A8A"/>
                 </a:solidFill>
               </a:defRPr>
             </a:pPr>
             <a:r>
-              <a:t>1. Edge-AI Diagnostics</a:t>
+              <a:t>Audit &amp; Database Vulnerabilities</a:t>
             </a:r>
           </a:p>
           <a:p>
             <a:pPr>
-              <a:defRPr sz="1100">
-                <a:solidFill>
-                  <a:srgbClr val="D1D5DB"/>
-                </a:solidFill>
-              </a:defRPr>
+              <a:spcBef>
+                <a:spcPts val="400"/>
+              </a:spcBef>
+              <a:spcAft>
+                <a:spcPts val="800"/>
+              </a:spcAft>
             </a:pPr>
             <a:r>
-              <a:t>Preprocesses 14 sensor channels and regresses RUL on an INT8-quantized TCN model in under 3 milliseconds.</a:t>
-            </a:r>
-          </a:p>
-        </p:txBody>
-      </p:sp>
-      <p:sp>
-        <p:nvSpPr>
-          <p:cNvPr id="6" name="Rectangle 5"/>
+              <a:rPr b="1" sz="1200">
+                <a:solidFill>
+                  <a:srgbClr val="1F2937"/>
+                </a:solidFill>
+                <a:latin typeface="Arial"/>
+              </a:rPr>
+              <a:t>• Retroactive Tampering: </a:t>
+            </a:r>
+            <a:r>
+              <a:rPr sz="1100">
+                <a:solidFill>
+                  <a:srgbClr val="4B5563"/>
+                </a:solidFill>
+                <a:latin typeface="Arial"/>
+              </a:rPr>
+              <a:t>Standard maintenance logs stored in centralized databases lack cryptographic seals, risking unauthorized tampering.</a:t>
+            </a:r>
+          </a:p>
+          <a:p>
+            <a:pPr>
+              <a:spcBef>
+                <a:spcPts val="400"/>
+              </a:spcBef>
+              <a:spcAft>
+                <a:spcPts val="800"/>
+              </a:spcAft>
+            </a:pPr>
+            <a:r>
+              <a:rPr b="1" sz="1200">
+                <a:solidFill>
+                  <a:srgbClr val="1F2937"/>
+                </a:solidFill>
+                <a:latin typeface="Arial"/>
+              </a:rPr>
+              <a:t>• Non-IID Operational Bias: </a:t>
+            </a:r>
+            <a:r>
+              <a:rPr sz="1100">
+                <a:solidFill>
+                  <a:srgbClr val="4B5563"/>
+                </a:solidFill>
+                <a:latin typeface="Arial"/>
+              </a:rPr>
+              <a:t>Operating conditions vary across MRO hubs. Centralized models become biased toward nominal or high-use fleets.</a:t>
+            </a:r>
+          </a:p>
+        </p:txBody>
+      </p:sp>
+    </p:spTree>
+  </p:cSld>
+  <p:clrMapOvr>
+    <a:masterClrMapping/>
+  </p:clrMapOvr>
+  <p:transition spd="med">
+    <p:fade/>
+  </p:transition>
+</p:sld>
+</file>
+
+<file path=ppt/slides/slide3.xml><?xml version="1.0" encoding="utf-8"?>
+<p:sld xmlns:a="http://schemas.openxmlformats.org/drawingml/2006/main" xmlns:p="http://schemas.openxmlformats.org/presentationml/2006/main" xmlns:r="http://schemas.openxmlformats.org/officeDocument/2006/relationships">
+  <p:cSld>
+    <p:bg>
+      <p:bgPr>
+        <a:solidFill>
+          <a:srgbClr val="FAFAFA"/>
+        </a:solidFill>
+        <a:effectLst/>
+      </p:bgPr>
+    </p:bg>
+    <p:spTree>
+      <p:nvGrpSpPr>
+        <p:cNvPr id="1" name=""/>
+        <p:cNvGrpSpPr/>
+        <p:nvPr/>
+      </p:nvGrpSpPr>
+      <p:grpSpPr/>
+      <p:sp>
+        <p:nvSpPr>
+          <p:cNvPr id="2" name="Rectangle 1"/>
           <p:cNvSpPr/>
           <p:nvPr/>
         </p:nvSpPr>
         <p:spPr>
           <a:xfrm>
-            <a:off x="3291840" y="1280160"/>
-            <a:ext cx="2560320" cy="3291840"/>
+            <a:off x="0" y="0"/>
+            <a:ext cx="9144000" cy="822960"/>
           </a:xfrm>
           <a:prstGeom prst="rect">
             <a:avLst/>
           </a:prstGeom>
           <a:solidFill>
-            <a:srgbClr val="111827"/>
+            <a:srgbClr val="F3F4F6"/>
           </a:solidFill>
           <a:ln w="12700">
             <a:solidFill>
-              <a:srgbClr val="6366F1"/>
+              <a:srgbClr val="E5E7EB"/>
             </a:solidFill>
           </a:ln>
         </p:spPr>
@@ -3818,57 +3688,105 @@
           </a:fontRef>
         </p:style>
         <p:txBody>
-          <a:bodyPr rtlCol="0" anchor="ctr" wrap="square" lIns="137160" rIns="137160" tIns="137160"/>
-          <a:lstStyle/>
-          <a:p>
-            <a:pPr algn="ctr">
-              <a:spcAft>
-                <a:spcPts val="1000"/>
-              </a:spcAft>
-              <a:defRPr sz="1400" b="1">
-                <a:solidFill>
-                  <a:srgbClr val="14B8A6"/>
-                </a:solidFill>
+          <a:bodyPr rtlCol="0" anchor="ctr"/>
+          <a:lstStyle/>
+          <a:p>
+            <a:pPr algn="ctr"/>
+          </a:p>
+        </p:txBody>
+      </p:sp>
+      <p:sp>
+        <p:nvSpPr>
+          <p:cNvPr id="3" name="TextBox 2"/>
+          <p:cNvSpPr txBox="1"/>
+          <p:nvPr/>
+        </p:nvSpPr>
+        <p:spPr>
+          <a:xfrm>
+            <a:off x="457200" y="109728"/>
+            <a:ext cx="5943600" cy="548640"/>
+          </a:xfrm>
+          <a:prstGeom prst="rect">
+            <a:avLst/>
+          </a:prstGeom>
+          <a:noFill/>
+        </p:spPr>
+        <p:txBody>
+          <a:bodyPr wrap="square" lIns="0" rIns="0" tIns="0" bIns="0">
+            <a:spAutoFit/>
+          </a:bodyPr>
+          <a:lstStyle/>
+          <a:p>
+            <a:pPr>
+              <a:defRPr sz="2000" b="1">
+                <a:solidFill>
+                  <a:srgbClr val="1E3A8A"/>
+                </a:solidFill>
+                <a:latin typeface="Arial"/>
               </a:defRPr>
             </a:pPr>
             <a:r>
-              <a:t>2. Privacy Federated Learning</a:t>
-            </a:r>
-          </a:p>
-          <a:p>
-            <a:pPr>
-              <a:defRPr sz="1100">
-                <a:solidFill>
-                  <a:srgbClr val="D1D5DB"/>
-                </a:solidFill>
+              <a:t>The Solution: SentinelMRO Architecture</a:t>
+            </a:r>
+          </a:p>
+        </p:txBody>
+      </p:sp>
+      <p:sp>
+        <p:nvSpPr>
+          <p:cNvPr id="4" name="TextBox 3"/>
+          <p:cNvSpPr txBox="1"/>
+          <p:nvPr/>
+        </p:nvSpPr>
+        <p:spPr>
+          <a:xfrm>
+            <a:off x="6400800" y="228600"/>
+            <a:ext cx="2286000" cy="365760"/>
+          </a:xfrm>
+          <a:prstGeom prst="rect">
+            <a:avLst/>
+          </a:prstGeom>
+          <a:noFill/>
+        </p:spPr>
+        <p:txBody>
+          <a:bodyPr wrap="square" lIns="0" rIns="0" tIns="0" bIns="0">
+            <a:spAutoFit/>
+          </a:bodyPr>
+          <a:lstStyle/>
+          <a:p>
+            <a:pPr algn="r">
+              <a:defRPr sz="950" b="1">
+                <a:solidFill>
+                  <a:srgbClr val="0D9488"/>
+                </a:solidFill>
+                <a:latin typeface="Arial"/>
               </a:defRPr>
             </a:pPr>
             <a:r>
-              <a:t>Executes cross-station FedProx local updates and aggregates gradients with Local Differential Privacy (LDP) perturbations.</a:t>
-            </a:r>
-          </a:p>
-        </p:txBody>
-      </p:sp>
-      <p:sp>
-        <p:nvSpPr>
-          <p:cNvPr id="7" name="Rectangle 6"/>
+              <a:t>Subsystem Overview</a:t>
+            </a:r>
+          </a:p>
+        </p:txBody>
+      </p:sp>
+      <p:sp>
+        <p:nvSpPr>
+          <p:cNvPr id="5" name="Rectangle 4"/>
           <p:cNvSpPr/>
           <p:nvPr/>
         </p:nvSpPr>
         <p:spPr>
           <a:xfrm>
-            <a:off x="6126480" y="1280160"/>
-            <a:ext cx="2560320" cy="3291840"/>
+            <a:off x="457200" y="1188720"/>
+            <a:ext cx="2560320" cy="3383280"/>
           </a:xfrm>
           <a:prstGeom prst="rect">
             <a:avLst/>
           </a:prstGeom>
           <a:solidFill>
-            <a:srgbClr val="111827"/>
+            <a:srgbClr val="F3F4F6"/>
           </a:solidFill>
           <a:ln w="12700">
             <a:solidFill>
-              <a:srgbClr val="6366F1"/>
+              <a:srgbClr val="E5E7EB"/>
             </a:solidFill>
           </a:ln>
         </p:spPr>
@@ -3892,78 +3810,52 @@
           <a:p>
             <a:pPr algn="ctr">
               <a:spcAft>
-                <a:spcPts val="1000"/>
+                <a:spcPts val="800"/>
               </a:spcAft>
-              <a:defRPr sz="1400" b="1">
-                <a:solidFill>
-                  <a:srgbClr val="14B8A6"/>
+              <a:defRPr sz="1300" b="1">
+                <a:solidFill>
+                  <a:srgbClr val="1E3A8A"/>
                 </a:solidFill>
               </a:defRPr>
             </a:pPr>
             <a:r>
-              <a:t>3. Cryptographic MMR Ledger</a:t>
+              <a:t>1. Edge-AI Diagnostics</a:t>
             </a:r>
           </a:p>
           <a:p>
             <a:pPr>
-              <a:defRPr sz="1100">
-                <a:solidFill>
-                  <a:srgbClr val="D1D5DB"/>
+              <a:defRPr sz="1050">
+                <a:solidFill>
+                  <a:srgbClr val="4B5563"/>
                 </a:solidFill>
               </a:defRPr>
             </a:pPr>
             <a:r>
-              <a:t>Validates Ed25519 edge signatures and logs events to an append-only Merkle Mountain Range database in SQLite.</a:t>
-            </a:r>
-          </a:p>
-        </p:txBody>
-      </p:sp>
-    </p:spTree>
-  </p:cSld>
-  <p:clrMapOvr>
-    <a:masterClrMapping/>
-  </p:clrMapOvr>
-</p:sld>
-</file>
-
-<file path=ppt/slides/slide4.xml><?xml version="1.0" encoding="utf-8"?>
-<p:sld xmlns:a="http://schemas.openxmlformats.org/drawingml/2006/main" xmlns:p="http://schemas.openxmlformats.org/presentationml/2006/main" xmlns:r="http://schemas.openxmlformats.org/officeDocument/2006/relationships">
-  <p:cSld>
-    <p:bg>
-      <p:bgPr>
-        <a:solidFill>
-          <a:srgbClr val="0A0A0C"/>
-        </a:solidFill>
-        <a:effectLst/>
-      </p:bgPr>
-    </p:bg>
-    <p:spTree>
-      <p:nvGrpSpPr>
-        <p:cNvPr id="1" name=""/>
-        <p:cNvGrpSpPr/>
-        <p:nvPr/>
-      </p:nvGrpSpPr>
-      <p:grpSpPr/>
-      <p:sp>
-        <p:nvSpPr>
-          <p:cNvPr id="2" name="Rectangle 1"/>
+              <a:t>Preprocesses 14 sensor channels and regresses RUL on an INT8-quantized TCN model in under 3 milliseconds.</a:t>
+            </a:r>
+          </a:p>
+        </p:txBody>
+      </p:sp>
+      <p:sp>
+        <p:nvSpPr>
+          <p:cNvPr id="6" name="Rectangle 5"/>
           <p:cNvSpPr/>
           <p:nvPr/>
         </p:nvSpPr>
         <p:spPr>
           <a:xfrm>
-            <a:off x="0" y="0"/>
-            <a:ext cx="9144000" cy="914400"/>
+            <a:off x="3291840" y="1188720"/>
+            <a:ext cx="2560320" cy="3383280"/>
           </a:xfrm>
           <a:prstGeom prst="rect">
             <a:avLst/>
           </a:prstGeom>
           <a:solidFill>
-            <a:srgbClr val="111827"/>
+            <a:srgbClr val="F3F4F6"/>
           </a:solidFill>
-          <a:ln w="19050">
+          <a:ln w="12700">
             <a:solidFill>
-              <a:srgbClr val="6366F1"/>
+              <a:srgbClr val="E5E7EB"/>
             </a:solidFill>
           </a:ln>
         </p:spPr>
@@ -3982,230 +3874,57 @@
           </a:fontRef>
         </p:style>
         <p:txBody>
-          <a:bodyPr rtlCol="0" anchor="ctr"/>
-          <a:lstStyle/>
-          <a:p>
-            <a:pPr algn="ctr"/>
-          </a:p>
-        </p:txBody>
-      </p:sp>
-      <p:sp>
-        <p:nvSpPr>
-          <p:cNvPr id="3" name="TextBox 2"/>
-          <p:cNvSpPr txBox="1"/>
-          <p:nvPr/>
-        </p:nvSpPr>
-        <p:spPr>
-          <a:xfrm>
-            <a:off x="457200" y="137160"/>
-            <a:ext cx="5943600" cy="640080"/>
-          </a:xfrm>
-          <a:prstGeom prst="rect">
-            <a:avLst/>
-          </a:prstGeom>
-          <a:noFill/>
-        </p:spPr>
-        <p:txBody>
-          <a:bodyPr wrap="square" lIns="0" rIns="0" tIns="0" bIns="0">
-            <a:spAutoFit/>
-          </a:bodyPr>
-          <a:lstStyle/>
-          <a:p>
-            <a:pPr>
-              <a:defRPr sz="2200" b="1">
-                <a:solidFill>
-                  <a:srgbClr val="FFFFFF"/>
-                </a:solidFill>
-                <a:latin typeface="Arial"/>
-              </a:defRPr>
-            </a:pPr>
-            <a:r>
-              <a:t>Phase 1: Quantized Causal TCN Engine</a:t>
-            </a:r>
-          </a:p>
-        </p:txBody>
-      </p:sp>
-      <p:sp>
-        <p:nvSpPr>
-          <p:cNvPr id="4" name="TextBox 3"/>
-          <p:cNvSpPr txBox="1"/>
-          <p:nvPr/>
-        </p:nvSpPr>
-        <p:spPr>
-          <a:xfrm>
-            <a:off x="6400800" y="274320"/>
-            <a:ext cx="2286000" cy="365760"/>
-          </a:xfrm>
-          <a:prstGeom prst="rect">
-            <a:avLst/>
-          </a:prstGeom>
-          <a:noFill/>
-        </p:spPr>
-        <p:txBody>
-          <a:bodyPr wrap="square" lIns="0" rIns="0" tIns="0" bIns="0">
-            <a:spAutoFit/>
-          </a:bodyPr>
-          <a:lstStyle/>
-          <a:p>
-            <a:pPr algn="r">
-              <a:defRPr sz="1000" b="1">
-                <a:solidFill>
-                  <a:srgbClr val="818CF8"/>
-                </a:solidFill>
-                <a:latin typeface="Arial"/>
-              </a:defRPr>
-            </a:pPr>
-            <a:r>
-              <a:t>Edge Inference</a:t>
-            </a:r>
-          </a:p>
-        </p:txBody>
-      </p:sp>
-      <p:sp>
-        <p:nvSpPr>
-          <p:cNvPr id="5" name="TextBox 4"/>
-          <p:cNvSpPr txBox="1"/>
-          <p:nvPr/>
-        </p:nvSpPr>
-        <p:spPr>
-          <a:xfrm>
-            <a:off x="457200" y="1188720"/>
-            <a:ext cx="8229600" cy="3474720"/>
-          </a:xfrm>
-          <a:prstGeom prst="rect">
-            <a:avLst/>
-          </a:prstGeom>
-          <a:noFill/>
-        </p:spPr>
-        <p:txBody>
-          <a:bodyPr wrap="square" lIns="0" rIns="0" tIns="0" bIns="0">
-            <a:spAutoFit/>
-          </a:bodyPr>
-          <a:lstStyle/>
-          <a:p/>
-          <a:p>
-            <a:pPr>
+          <a:bodyPr rtlCol="0" anchor="ctr" wrap="square" lIns="137160" rIns="137160" tIns="137160"/>
+          <a:lstStyle/>
+          <a:p>
+            <a:pPr algn="ctr">
               <a:spcAft>
                 <a:spcPts val="800"/>
               </a:spcAft>
+              <a:defRPr sz="1300" b="1">
+                <a:solidFill>
+                  <a:srgbClr val="1E3A8A"/>
+                </a:solidFill>
+              </a:defRPr>
             </a:pPr>
             <a:r>
-              <a:rPr b="1" sz="1300">
-                <a:solidFill>
-                  <a:srgbClr val="FFFFFF"/>
-                </a:solidFill>
-                <a:latin typeface="Arial"/>
-              </a:rPr>
-              <a:t>• Data Sanitization: </a:t>
-            </a:r>
-            <a:r>
-              <a:rPr sz="1200">
-                <a:solidFill>
-                  <a:srgbClr val="D1D5DB"/>
-                </a:solidFill>
-                <a:latin typeface="Arial"/>
-              </a:rPr>
-              <a:t>Strips out 7 zero-variance constant sensor channels. Fits localized MinMaxScaler within a strict [0, 1] bounds.</a:t>
+              <a:t>2. Privacy Federated Learning</a:t>
             </a:r>
           </a:p>
           <a:p>
             <a:pPr>
-              <a:spcAft>
-                <a:spcPts val="800"/>
-              </a:spcAft>
+              <a:defRPr sz="1050">
+                <a:solidFill>
+                  <a:srgbClr val="4B5563"/>
+                </a:solidFill>
+              </a:defRPr>
             </a:pPr>
             <a:r>
-              <a:rPr b="1" sz="1300">
-                <a:solidFill>
-                  <a:srgbClr val="FFFFFF"/>
-                </a:solidFill>
-                <a:latin typeface="Arial"/>
-              </a:rPr>
-              <a:t>• Temporal Convolutional Network: </a:t>
-            </a:r>
-            <a:r>
-              <a:rPr sz="1200">
-                <a:solidFill>
-                  <a:srgbClr val="D1D5DB"/>
-                </a:solidFill>
-                <a:latin typeface="Arial"/>
-              </a:rPr>
-              <a:t>Replaces slow LSTMs. Utilizes exponential dilations (1, 2, 4, 8) with kernel size k=3. Parallel causal convolutions ensure O(1) latency.</a:t>
-            </a:r>
-          </a:p>
-          <a:p>
-            <a:pPr>
-              <a:spcAft>
-                <a:spcPts val="800"/>
-              </a:spcAft>
-            </a:pPr>
-            <a:r>
-              <a:rPr b="1" sz="1300">
-                <a:solidFill>
-                  <a:srgbClr val="FFFFFF"/>
-                </a:solidFill>
-                <a:latin typeface="Arial"/>
-              </a:rPr>
-              <a:t>• Dynamic INT8 Quantization: </a:t>
-            </a:r>
-            <a:r>
-              <a:rPr sz="1200">
-                <a:solidFill>
-                  <a:srgbClr val="D1D5DB"/>
-                </a:solidFill>
-                <a:latin typeface="Arial"/>
-              </a:rPr>
-              <a:t>Removes training weight normalization hooks (remove_weight_norm). Quantizes ONNX weights dynamically, reducing footprint and allowing CPU execution in &lt; 3ms.</a:t>
-            </a:r>
-          </a:p>
-        </p:txBody>
-      </p:sp>
-    </p:spTree>
-  </p:cSld>
-  <p:clrMapOvr>
-    <a:masterClrMapping/>
-  </p:clrMapOvr>
-</p:sld>
-</file>
-
-<file path=ppt/slides/slide5.xml><?xml version="1.0" encoding="utf-8"?>
-<p:sld xmlns:a="http://schemas.openxmlformats.org/drawingml/2006/main" xmlns:p="http://schemas.openxmlformats.org/presentationml/2006/main" xmlns:r="http://schemas.openxmlformats.org/officeDocument/2006/relationships">
-  <p:cSld>
-    <p:bg>
-      <p:bgPr>
-        <a:solidFill>
-          <a:srgbClr val="0A0A0C"/>
-        </a:solidFill>
-        <a:effectLst/>
-      </p:bgPr>
-    </p:bg>
-    <p:spTree>
-      <p:nvGrpSpPr>
-        <p:cNvPr id="1" name=""/>
-        <p:cNvGrpSpPr/>
-        <p:nvPr/>
-      </p:nvGrpSpPr>
-      <p:grpSpPr/>
-      <p:sp>
-        <p:nvSpPr>
-          <p:cNvPr id="2" name="Rectangle 1"/>
+              <a:t>Executes cross-station FedProx local updates and aggregates gradients with Local Differential Privacy (LDP) perturbations.</a:t>
+            </a:r>
+          </a:p>
+        </p:txBody>
+      </p:sp>
+      <p:sp>
+        <p:nvSpPr>
+          <p:cNvPr id="7" name="Rectangle 6"/>
           <p:cNvSpPr/>
           <p:nvPr/>
         </p:nvSpPr>
         <p:spPr>
           <a:xfrm>
-            <a:off x="0" y="0"/>
-            <a:ext cx="9144000" cy="914400"/>
+            <a:off x="6126480" y="1188720"/>
+            <a:ext cx="2560320" cy="3383280"/>
           </a:xfrm>
           <a:prstGeom prst="rect">
             <a:avLst/>
           </a:prstGeom>
           <a:solidFill>
-            <a:srgbClr val="111827"/>
+            <a:srgbClr val="F3F4F6"/>
           </a:solidFill>
-          <a:ln w="19050">
+          <a:ln w="12700">
             <a:solidFill>
-              <a:srgbClr val="6366F1"/>
+              <a:srgbClr val="E5E7EB"/>
             </a:solidFill>
           </a:ln>
         </p:spPr>
@@ -4224,180 +3943,33 @@
           </a:fontRef>
         </p:style>
         <p:txBody>
-          <a:bodyPr rtlCol="0" anchor="ctr"/>
-          <a:lstStyle/>
-          <a:p>
-            <a:pPr algn="ctr"/>
-          </a:p>
-        </p:txBody>
-      </p:sp>
-      <p:sp>
-        <p:nvSpPr>
-          <p:cNvPr id="3" name="TextBox 2"/>
-          <p:cNvSpPr txBox="1"/>
-          <p:nvPr/>
-        </p:nvSpPr>
-        <p:spPr>
-          <a:xfrm>
-            <a:off x="457200" y="137160"/>
-            <a:ext cx="5943600" cy="640080"/>
-          </a:xfrm>
-          <a:prstGeom prst="rect">
-            <a:avLst/>
-          </a:prstGeom>
-          <a:noFill/>
-        </p:spPr>
-        <p:txBody>
-          <a:bodyPr wrap="square" lIns="0" rIns="0" tIns="0" bIns="0">
-            <a:spAutoFit/>
-          </a:bodyPr>
-          <a:lstStyle/>
-          <a:p>
-            <a:pPr>
-              <a:defRPr sz="2200" b="1">
-                <a:solidFill>
-                  <a:srgbClr val="FFFFFF"/>
-                </a:solidFill>
-                <a:latin typeface="Arial"/>
-              </a:defRPr>
-            </a:pPr>
-            <a:r>
-              <a:t>Phase 2: FedProx &amp; LDP Collaborative Learning</a:t>
-            </a:r>
-          </a:p>
-        </p:txBody>
-      </p:sp>
-      <p:sp>
-        <p:nvSpPr>
-          <p:cNvPr id="4" name="TextBox 3"/>
-          <p:cNvSpPr txBox="1"/>
-          <p:nvPr/>
-        </p:nvSpPr>
-        <p:spPr>
-          <a:xfrm>
-            <a:off x="6400800" y="274320"/>
-            <a:ext cx="2286000" cy="365760"/>
-          </a:xfrm>
-          <a:prstGeom prst="rect">
-            <a:avLst/>
-          </a:prstGeom>
-          <a:noFill/>
-        </p:spPr>
-        <p:txBody>
-          <a:bodyPr wrap="square" lIns="0" rIns="0" tIns="0" bIns="0">
-            <a:spAutoFit/>
-          </a:bodyPr>
-          <a:lstStyle/>
-          <a:p>
-            <a:pPr algn="r">
-              <a:defRPr sz="1000" b="1">
-                <a:solidFill>
-                  <a:srgbClr val="818CF8"/>
-                </a:solidFill>
-                <a:latin typeface="Arial"/>
-              </a:defRPr>
-            </a:pPr>
-            <a:r>
-              <a:t>Federated Optimization</a:t>
-            </a:r>
-          </a:p>
-        </p:txBody>
-      </p:sp>
-      <p:sp>
-        <p:nvSpPr>
-          <p:cNvPr id="5" name="TextBox 4"/>
-          <p:cNvSpPr txBox="1"/>
-          <p:nvPr/>
-        </p:nvSpPr>
-        <p:spPr>
-          <a:xfrm>
-            <a:off x="457200" y="1188720"/>
-            <a:ext cx="8229600" cy="3474720"/>
-          </a:xfrm>
-          <a:prstGeom prst="rect">
-            <a:avLst/>
-          </a:prstGeom>
-          <a:noFill/>
-        </p:spPr>
-        <p:txBody>
-          <a:bodyPr wrap="square" lIns="0" rIns="0" tIns="0" bIns="0">
-            <a:spAutoFit/>
-          </a:bodyPr>
-          <a:lstStyle/>
-          <a:p/>
-          <a:p>
-            <a:pPr>
+          <a:bodyPr rtlCol="0" anchor="ctr" wrap="square" lIns="137160" rIns="137160" tIns="137160"/>
+          <a:lstStyle/>
+          <a:p>
+            <a:pPr algn="ctr">
               <a:spcAft>
                 <a:spcPts val="800"/>
               </a:spcAft>
+              <a:defRPr sz="1300" b="1">
+                <a:solidFill>
+                  <a:srgbClr val="1E3A8A"/>
+                </a:solidFill>
+              </a:defRPr>
             </a:pPr>
             <a:r>
-              <a:rPr b="1" sz="1300">
-                <a:solidFill>
-                  <a:srgbClr val="FFFFFF"/>
-                </a:solidFill>
-                <a:latin typeface="Arial"/>
-              </a:rPr>
-              <a:t>• Non-IID Partitioning: </a:t>
-            </a:r>
-            <a:r>
-              <a:rPr sz="1200">
-                <a:solidFill>
-                  <a:srgbClr val="D1D5DB"/>
-                </a:solidFill>
-                <a:latin typeface="Arial"/>
-              </a:rPr>
-              <a:t>Splits the NASA dataset into 3 operational clusters simulating different MRO hubs: Nominal (ST-1), High-stress (ST-2), and Mixed (ST-3).</a:t>
+              <a:t>3. Cryptographic MMR Ledger</a:t>
             </a:r>
           </a:p>
           <a:p>
             <a:pPr>
-              <a:spcAft>
-                <a:spcPts val="800"/>
-              </a:spcAft>
+              <a:defRPr sz="1050">
+                <a:solidFill>
+                  <a:srgbClr val="4B5563"/>
+                </a:solidFill>
+              </a:defRPr>
             </a:pPr>
             <a:r>
-              <a:rPr b="1" sz="1300">
-                <a:solidFill>
-                  <a:srgbClr val="FFFFFF"/>
-                </a:solidFill>
-                <a:latin typeface="Arial"/>
-              </a:rPr>
-              <a:t>• FedProx Regularization: </a:t>
-            </a:r>
-            <a:r>
-              <a:rPr sz="1200">
-                <a:solidFill>
-                  <a:srgbClr val="D1D5DB"/>
-                </a:solidFill>
-                <a:latin typeface="Arial"/>
-              </a:rPr>
-              <a:t>Appends a proximal regularization penalty to local loss loops: (mu / 2) * || w - w^t ||^2. Solves data distribution mismatch and stabilizes local weight adjustments.</a:t>
-            </a:r>
-          </a:p>
-          <a:p>
-            <a:pPr>
-              <a:spcAft>
-                <a:spcPts val="800"/>
-              </a:spcAft>
-            </a:pPr>
-            <a:r>
-              <a:rPr b="1" sz="1300">
-                <a:solidFill>
-                  <a:srgbClr val="FFFFFF"/>
-                </a:solidFill>
-                <a:latin typeface="Arial"/>
-              </a:rPr>
-              <a:t>• Local Differential Privacy: </a:t>
-            </a:r>
-            <a:r>
-              <a:rPr sz="1200">
-                <a:solidFill>
-                  <a:srgbClr val="D1D5DB"/>
-                </a:solidFill>
-                <a:latin typeface="Arial"/>
-              </a:rPr>
-              <a:t>Injects calibrated Gaussian noise w_priv = w_local + N(0, 0.001^2) to parameters before gateway aggregation to protect client telemetry.</a:t>
+              <a:t>Validates Ed25519 edge signatures and logs events to an append-only Merkle Mountain Range database in SQLite.</a:t>
             </a:r>
           </a:p>
         </p:txBody>
@@ -4407,16 +3979,19 @@
   <p:clrMapOvr>
     <a:masterClrMapping/>
   </p:clrMapOvr>
+  <p:transition spd="med">
+    <p:fade/>
+  </p:transition>
 </p:sld>
 </file>
 
-<file path=ppt/slides/slide6.xml><?xml version="1.0" encoding="utf-8"?>
+<file path=ppt/slides/slide4.xml><?xml version="1.0" encoding="utf-8"?>
 <p:sld xmlns:a="http://schemas.openxmlformats.org/drawingml/2006/main" xmlns:p="http://schemas.openxmlformats.org/presentationml/2006/main" xmlns:r="http://schemas.openxmlformats.org/officeDocument/2006/relationships">
   <p:cSld>
     <p:bg>
       <p:bgPr>
         <a:solidFill>
-          <a:srgbClr val="0A0A0C"/>
+          <a:srgbClr val="FAFAFA"/>
         </a:solidFill>
         <a:effectLst/>
       </p:bgPr>
@@ -4437,17 +4012,17 @@
         <p:spPr>
           <a:xfrm>
             <a:off x="0" y="0"/>
-            <a:ext cx="9144000" cy="914400"/>
+            <a:ext cx="9144000" cy="822960"/>
           </a:xfrm>
           <a:prstGeom prst="rect">
             <a:avLst/>
           </a:prstGeom>
           <a:solidFill>
-            <a:srgbClr val="111827"/>
+            <a:srgbClr val="F3F4F6"/>
           </a:solidFill>
-          <a:ln w="19050">
+          <a:ln w="12700">
             <a:solidFill>
-              <a:srgbClr val="6366F1"/>
+              <a:srgbClr val="E5E7EB"/>
             </a:solidFill>
           </a:ln>
         </p:spPr>
@@ -4481,8 +4056,8 @@
         </p:nvSpPr>
         <p:spPr>
           <a:xfrm>
-            <a:off x="457200" y="137160"/>
-            <a:ext cx="5943600" cy="640080"/>
+            <a:off x="457200" y="109728"/>
+            <a:ext cx="5943600" cy="548640"/>
           </a:xfrm>
           <a:prstGeom prst="rect">
             <a:avLst/>
@@ -4496,15 +4071,15 @@
           <a:lstStyle/>
           <a:p>
             <a:pPr>
-              <a:defRPr sz="2200" b="1">
-                <a:solidFill>
-                  <a:srgbClr val="FFFFFF"/>
+              <a:defRPr sz="2000" b="1">
+                <a:solidFill>
+                  <a:srgbClr val="1E3A8A"/>
                 </a:solidFill>
                 <a:latin typeface="Arial"/>
               </a:defRPr>
             </a:pPr>
             <a:r>
-              <a:t>Phase 3: Cryptographic SQLite MMR Ledger</a:t>
+              <a:t>Phase 1: Quantized Causal TCN Engine</a:t>
             </a:r>
           </a:p>
         </p:txBody>
@@ -4517,7 +4092,7 @@
         </p:nvSpPr>
         <p:spPr>
           <a:xfrm>
-            <a:off x="6400800" y="274320"/>
+            <a:off x="6400800" y="228600"/>
             <a:ext cx="2286000" cy="365760"/>
           </a:xfrm>
           <a:prstGeom prst="rect">
@@ -4532,15 +4107,15 @@
           <a:lstStyle/>
           <a:p>
             <a:pPr algn="r">
-              <a:defRPr sz="1000" b="1">
-                <a:solidFill>
-                  <a:srgbClr val="818CF8"/>
+              <a:defRPr sz="950" b="1">
+                <a:solidFill>
+                  <a:srgbClr val="0D9488"/>
                 </a:solidFill>
                 <a:latin typeface="Arial"/>
               </a:defRPr>
             </a:pPr>
             <a:r>
-              <a:t>Audit &amp; Security</a:t>
+              <a:t>Edge Inference</a:t>
             </a:r>
           </a:p>
         </p:txBody>
@@ -4554,7 +4129,7 @@
         <p:spPr>
           <a:xfrm>
             <a:off x="457200" y="1188720"/>
-            <a:ext cx="8229600" cy="3474720"/>
+            <a:ext cx="4572000" cy="3383280"/>
           </a:xfrm>
           <a:prstGeom prst="rect">
             <a:avLst/>
@@ -4569,77 +4144,86 @@
           <a:p/>
           <a:p>
             <a:pPr>
+              <a:spcBef>
+                <a:spcPts val="400"/>
+              </a:spcBef>
               <a:spcAft>
                 <a:spcPts val="800"/>
               </a:spcAft>
             </a:pPr>
             <a:r>
-              <a:rPr b="1" sz="1300">
-                <a:solidFill>
-                  <a:srgbClr val="FFFFFF"/>
+              <a:rPr b="1" sz="1200">
+                <a:solidFill>
+                  <a:srgbClr val="1F2937"/>
                 </a:solidFill>
                 <a:latin typeface="Arial"/>
               </a:rPr>
-              <a:t>• Ed25519 Payload Signing: </a:t>
-            </a:r>
-            <a:r>
-              <a:rPr sz="1200">
-                <a:solidFill>
-                  <a:srgbClr val="D1D5DB"/>
+              <a:t>• Data Preprocessing: </a:t>
+            </a:r>
+            <a:r>
+              <a:rPr sz="1100">
+                <a:solidFill>
+                  <a:srgbClr val="4B5563"/>
                 </a:solidFill>
                 <a:latin typeface="Arial"/>
               </a:rPr>
-              <a:t>Transactions generated at MRO edge nodes must include a signature. Verified at the gateway using station public keys, preventing spoofing.</a:t>
+              <a:t>Strips 7 low-variance constants, keeping 14 features scaled locally via MinMaxScaler [0, 1] over 30 cycles.</a:t>
             </a:r>
           </a:p>
           <a:p>
             <a:pPr>
+              <a:spcBef>
+                <a:spcPts val="400"/>
+              </a:spcBef>
               <a:spcAft>
                 <a:spcPts val="800"/>
               </a:spcAft>
             </a:pPr>
             <a:r>
-              <a:rPr b="1" sz="1300">
-                <a:solidFill>
-                  <a:srgbClr val="FFFFFF"/>
+              <a:rPr b="1" sz="1200">
+                <a:solidFill>
+                  <a:srgbClr val="1F2937"/>
                 </a:solidFill>
                 <a:latin typeface="Arial"/>
               </a:rPr>
-              <a:t>• Merkle Mountain Range (MMR): </a:t>
-            </a:r>
-            <a:r>
-              <a:rPr sz="1200">
-                <a:solidFill>
-                  <a:srgbClr val="D1D5DB"/>
+              <a:t>• Dilated Conv1D Network: </a:t>
+            </a:r>
+            <a:r>
+              <a:rPr sz="1100">
+                <a:solidFill>
+                  <a:srgbClr val="4B5563"/>
                 </a:solidFill>
                 <a:latin typeface="Arial"/>
               </a:rPr>
-              <a:t>Appends nodes to a binary tree in post-order flat indexing. Enables O(log n) inclusion proofs and rapid integrity verification checks.</a:t>
+              <a:t>Causal padding ensures outputs at cycle t depend only on past cycles. Exponential dilations (1, 2, 4, 8) enable O(1) latency.</a:t>
             </a:r>
           </a:p>
           <a:p>
             <a:pPr>
+              <a:spcBef>
+                <a:spcPts val="400"/>
+              </a:spcBef>
               <a:spcAft>
                 <a:spcPts val="800"/>
               </a:spcAft>
             </a:pPr>
             <a:r>
-              <a:rPr b="1" sz="1300">
-                <a:solidFill>
-                  <a:srgbClr val="FFFFFF"/>
+              <a:rPr b="1" sz="1200">
+                <a:solidFill>
+                  <a:srgbClr val="1F2937"/>
                 </a:solidFill>
                 <a:latin typeface="Arial"/>
               </a:rPr>
-              <a:t>• Tamper Detection Backdoor: </a:t>
-            </a:r>
-            <a:r>
-              <a:rPr sz="1200">
-                <a:solidFill>
-                  <a:srgbClr val="D1D5DB"/>
+              <a:t>• Quantization &amp; Hot Swap: </a:t>
+            </a:r>
+            <a:r>
+              <a:rPr sz="1100">
+                <a:solidFill>
+                  <a:srgbClr val="4B5563"/>
                 </a:solidFill>
                 <a:latin typeface="Arial"/>
               </a:rPr>
-              <a:t>Updates SQLite columns directly without re-building peaks or leaf hashes. Integrity check fails instantly on root hash mismatch, highlighting altered rows.</a:t>
+              <a:t>Strips PyTorch weight norm hooks, exporting a clean graph. Dynamic INT8 quantization compresses size 4x, achieving &lt; 3ms CPU inference.</a:t>
             </a:r>
           </a:p>
         </p:txBody>
@@ -4649,16 +4233,19 @@
   <p:clrMapOvr>
     <a:masterClrMapping/>
   </p:clrMapOvr>
+  <p:transition spd="med">
+    <p:fade/>
+  </p:transition>
 </p:sld>
 </file>
 
-<file path=ppt/slides/slide7.xml><?xml version="1.0" encoding="utf-8"?>
+<file path=ppt/slides/slide5.xml><?xml version="1.0" encoding="utf-8"?>
 <p:sld xmlns:a="http://schemas.openxmlformats.org/drawingml/2006/main" xmlns:p="http://schemas.openxmlformats.org/presentationml/2006/main" xmlns:r="http://schemas.openxmlformats.org/officeDocument/2006/relationships">
   <p:cSld>
     <p:bg>
       <p:bgPr>
         <a:solidFill>
-          <a:srgbClr val="0A0A0C"/>
+          <a:srgbClr val="FAFAFA"/>
         </a:solidFill>
         <a:effectLst/>
       </p:bgPr>
@@ -4679,17 +4266,17 @@
         <p:spPr>
           <a:xfrm>
             <a:off x="0" y="0"/>
-            <a:ext cx="9144000" cy="914400"/>
+            <a:ext cx="9144000" cy="822960"/>
           </a:xfrm>
           <a:prstGeom prst="rect">
             <a:avLst/>
           </a:prstGeom>
           <a:solidFill>
-            <a:srgbClr val="111827"/>
+            <a:srgbClr val="F3F4F6"/>
           </a:solidFill>
-          <a:ln w="19050">
+          <a:ln w="12700">
             <a:solidFill>
-              <a:srgbClr val="6366F1"/>
+              <a:srgbClr val="E5E7EB"/>
             </a:solidFill>
           </a:ln>
         </p:spPr>
@@ -4723,8 +4310,8 @@
         </p:nvSpPr>
         <p:spPr>
           <a:xfrm>
-            <a:off x="457200" y="137160"/>
-            <a:ext cx="5943600" cy="640080"/>
+            <a:off x="457200" y="109728"/>
+            <a:ext cx="5943600" cy="548640"/>
           </a:xfrm>
           <a:prstGeom prst="rect">
             <a:avLst/>
@@ -4738,15 +4325,15 @@
           <a:lstStyle/>
           <a:p>
             <a:pPr>
-              <a:defRPr sz="2200" b="1">
-                <a:solidFill>
-                  <a:srgbClr val="FFFFFF"/>
+              <a:defRPr sz="2000" b="1">
+                <a:solidFill>
+                  <a:srgbClr val="1E3A8A"/>
                 </a:solidFill>
                 <a:latin typeface="Arial"/>
               </a:defRPr>
             </a:pPr>
             <a:r>
-              <a:t>Phase 4: Next.js 15 Command Console</a:t>
+              <a:t>Phase 2: FedProx &amp; LDP Collaborative Learning</a:t>
             </a:r>
           </a:p>
         </p:txBody>
@@ -4759,7 +4346,7 @@
         </p:nvSpPr>
         <p:spPr>
           <a:xfrm>
-            <a:off x="6400800" y="274320"/>
+            <a:off x="6400800" y="228600"/>
             <a:ext cx="2286000" cy="365760"/>
           </a:xfrm>
           <a:prstGeom prst="rect">
@@ -4774,15 +4361,15 @@
           <a:lstStyle/>
           <a:p>
             <a:pPr algn="r">
-              <a:defRPr sz="1000" b="1">
-                <a:solidFill>
-                  <a:srgbClr val="818CF8"/>
+              <a:defRPr sz="950" b="1">
+                <a:solidFill>
+                  <a:srgbClr val="0D9488"/>
                 </a:solidFill>
                 <a:latin typeface="Arial"/>
               </a:defRPr>
             </a:pPr>
             <a:r>
-              <a:t>User Interface &amp; Control</a:t>
+              <a:t>Federated Optimization</a:t>
             </a:r>
           </a:p>
         </p:txBody>
@@ -4796,7 +4383,7 @@
         <p:spPr>
           <a:xfrm>
             <a:off x="457200" y="1188720"/>
-            <a:ext cx="8229600" cy="3474720"/>
+            <a:ext cx="4572000" cy="3383280"/>
           </a:xfrm>
           <a:prstGeom prst="rect">
             <a:avLst/>
@@ -4811,77 +4398,86 @@
           <a:p/>
           <a:p>
             <a:pPr>
+              <a:spcBef>
+                <a:spcPts val="400"/>
+              </a:spcBef>
               <a:spcAft>
                 <a:spcPts val="800"/>
               </a:spcAft>
             </a:pPr>
             <a:r>
-              <a:rPr b="1" sz="1300">
-                <a:solidFill>
-                  <a:srgbClr val="FFFFFF"/>
+              <a:rPr b="1" sz="1200">
+                <a:solidFill>
+                  <a:srgbClr val="1F2937"/>
                 </a:solidFill>
                 <a:latin typeface="Arial"/>
               </a:rPr>
-              <a:t>• Premium Dark Industrial Theme: </a:t>
-            </a:r>
-            <a:r>
-              <a:rPr sz="1200">
-                <a:solidFill>
-                  <a:srgbClr val="D1D5DB"/>
+              <a:t>• Non-IID Operational Clusters: </a:t>
+            </a:r>
+            <a:r>
+              <a:rPr sz="1100">
+                <a:solidFill>
+                  <a:srgbClr val="4B5563"/>
                 </a:solidFill>
                 <a:latin typeface="Arial"/>
               </a:rPr>
-              <a:t>Built on bg-zinc-950 and text-zinc-50 with responsive, sleek glassmorphism panels.</a:t>
+              <a:t>Splits the C-MAPSS dataset into 3 operational clusters: Nominal (cycles &lt;= 60), Stress-State (cycles &gt; 100), and Mixed.</a:t>
             </a:r>
           </a:p>
           <a:p>
             <a:pPr>
+              <a:spcBef>
+                <a:spcPts val="400"/>
+              </a:spcBef>
               <a:spcAft>
                 <a:spcPts val="800"/>
               </a:spcAft>
             </a:pPr>
             <a:r>
-              <a:rPr b="1" sz="1300">
-                <a:solidFill>
-                  <a:srgbClr val="FFFFFF"/>
+              <a:rPr b="1" sz="1200">
+                <a:solidFill>
+                  <a:srgbClr val="1F2937"/>
                 </a:solidFill>
                 <a:latin typeface="Arial"/>
               </a:rPr>
-              <a:t>• Real-time Telemetry plots: </a:t>
-            </a:r>
-            <a:r>
-              <a:rPr sz="1200">
-                <a:solidFill>
-                  <a:srgbClr val="D1D5DB"/>
+              <a:t>• FedProx Regularizer Penalty: </a:t>
+            </a:r>
+            <a:r>
+              <a:rPr sz="1100">
+                <a:solidFill>
+                  <a:srgbClr val="4B5563"/>
                 </a:solidFill>
                 <a:latin typeface="Arial"/>
               </a:rPr>
-              <a:t>Integrates interactive Recharts line curves linking predicted TCN RUL with high-frequency core speed and bypass ratio trends.</a:t>
+              <a:t>Modifies local loss: (mu/2) * ||w - w_t||^2 where mu=0.01. Stabilizes optimization updates under non-IID conditions.</a:t>
             </a:r>
           </a:p>
           <a:p>
             <a:pPr>
+              <a:spcBef>
+                <a:spcPts val="400"/>
+              </a:spcBef>
               <a:spcAft>
                 <a:spcPts val="800"/>
               </a:spcAft>
             </a:pPr>
             <a:r>
-              <a:rPr b="1" sz="1300">
-                <a:solidFill>
-                  <a:srgbClr val="FFFFFF"/>
+              <a:rPr b="1" sz="1200">
+                <a:solidFill>
+                  <a:srgbClr val="1F2937"/>
                 </a:solidFill>
                 <a:latin typeface="Arial"/>
               </a:rPr>
-              <a:t>• Interactive Security Console: </a:t>
-            </a:r>
-            <a:r>
-              <a:rPr sz="1200">
-                <a:solidFill>
-                  <a:srgbClr val="D1D5DB"/>
+              <a:t>• Local Differential Privacy: </a:t>
+            </a:r>
+            <a:r>
+              <a:rPr sz="1100">
+                <a:solidFill>
+                  <a:srgbClr val="4B5563"/>
                 </a:solidFill>
                 <a:latin typeface="Arial"/>
               </a:rPr>
-              <a:t>Features buttons to Verify Ecosystem Integrity or Simulate Malicious Database Injection. Alerts flash red dynamically on tampering validation mismatch.</a:t>
+              <a:t>Adds calibrated Gaussian noise N(0, 0.001^2) to parameters before aggregation to mathematically block model inversion attacks.</a:t>
             </a:r>
           </a:p>
         </p:txBody>
@@ -4891,16 +4487,19 @@
   <p:clrMapOvr>
     <a:masterClrMapping/>
   </p:clrMapOvr>
+  <p:transition spd="med">
+    <p:fade/>
+  </p:transition>
 </p:sld>
 </file>
 
-<file path=ppt/slides/slide8.xml><?xml version="1.0" encoding="utf-8"?>
+<file path=ppt/slides/slide6.xml><?xml version="1.0" encoding="utf-8"?>
 <p:sld xmlns:a="http://schemas.openxmlformats.org/drawingml/2006/main" xmlns:p="http://schemas.openxmlformats.org/presentationml/2006/main" xmlns:r="http://schemas.openxmlformats.org/officeDocument/2006/relationships">
   <p:cSld>
     <p:bg>
       <p:bgPr>
         <a:solidFill>
-          <a:srgbClr val="0A0A0C"/>
+          <a:srgbClr val="FAFAFA"/>
         </a:solidFill>
         <a:effectLst/>
       </p:bgPr>
@@ -4921,17 +4520,17 @@
         <p:spPr>
           <a:xfrm>
             <a:off x="0" y="0"/>
-            <a:ext cx="9144000" cy="914400"/>
+            <a:ext cx="9144000" cy="822960"/>
           </a:xfrm>
           <a:prstGeom prst="rect">
             <a:avLst/>
           </a:prstGeom>
           <a:solidFill>
-            <a:srgbClr val="111827"/>
+            <a:srgbClr val="F3F4F6"/>
           </a:solidFill>
-          <a:ln w="19050">
+          <a:ln w="12700">
             <a:solidFill>
-              <a:srgbClr val="6366F1"/>
+              <a:srgbClr val="E5E7EB"/>
             </a:solidFill>
           </a:ln>
         </p:spPr>
@@ -4965,8 +4564,8 @@
         </p:nvSpPr>
         <p:spPr>
           <a:xfrm>
-            <a:off x="457200" y="137160"/>
-            <a:ext cx="5943600" cy="640080"/>
+            <a:off x="457200" y="109728"/>
+            <a:ext cx="5943600" cy="548640"/>
           </a:xfrm>
           <a:prstGeom prst="rect">
             <a:avLst/>
@@ -4980,15 +4579,15 @@
           <a:lstStyle/>
           <a:p>
             <a:pPr>
-              <a:defRPr sz="2200" b="1">
-                <a:solidFill>
-                  <a:srgbClr val="FFFFFF"/>
+              <a:defRPr sz="2000" b="1">
+                <a:solidFill>
+                  <a:srgbClr val="1E3A8A"/>
                 </a:solidFill>
                 <a:latin typeface="Arial"/>
               </a:defRPr>
             </a:pPr>
             <a:r>
-              <a:t>Worked Trace Example: Maintenance Logging</a:t>
+              <a:t>Phase 3: Cryptographic SQLite MMR Ledger</a:t>
             </a:r>
           </a:p>
         </p:txBody>
@@ -5001,7 +4600,7 @@
         </p:nvSpPr>
         <p:spPr>
           <a:xfrm>
-            <a:off x="6400800" y="274320"/>
+            <a:off x="6400800" y="228600"/>
             <a:ext cx="2286000" cy="365760"/>
           </a:xfrm>
           <a:prstGeom prst="rect">
@@ -5016,269 +4615,39 @@
           <a:lstStyle/>
           <a:p>
             <a:pPr algn="r">
-              <a:defRPr sz="1000" b="1">
-                <a:solidFill>
-                  <a:srgbClr val="818CF8"/>
+              <a:defRPr sz="950" b="1">
+                <a:solidFill>
+                  <a:srgbClr val="0D9488"/>
                 </a:solidFill>
                 <a:latin typeface="Arial"/>
               </a:defRPr>
             </a:pPr>
             <a:r>
-              <a:t>Ecosystem in Action</a:t>
-            </a:r>
-          </a:p>
-        </p:txBody>
-      </p:sp>
-      <p:sp>
-        <p:nvSpPr>
-          <p:cNvPr id="5" name="TextBox 4"/>
-          <p:cNvSpPr txBox="1"/>
-          <p:nvPr/>
-        </p:nvSpPr>
-        <p:spPr>
-          <a:xfrm>
-            <a:off x="457200" y="1188720"/>
-            <a:ext cx="3931920" cy="3474720"/>
-          </a:xfrm>
-          <a:prstGeom prst="rect">
-            <a:avLst/>
-          </a:prstGeom>
-          <a:noFill/>
-        </p:spPr>
-        <p:txBody>
-          <a:bodyPr wrap="square" lIns="0" rIns="0" tIns="0" bIns="0">
-            <a:spAutoFit/>
-          </a:bodyPr>
-          <a:lstStyle/>
-          <a:p>
-            <a:pPr>
-              <a:spcBef>
-                <a:spcPts val="600"/>
-              </a:spcBef>
-              <a:spcAft>
-                <a:spcPts val="600"/>
-              </a:spcAft>
-              <a:defRPr sz="1400" b="1">
-                <a:solidFill>
-                  <a:srgbClr val="14B8A6"/>
-                </a:solidFill>
-              </a:defRPr>
-            </a:pPr>
-            <a:r>
-              <a:t>Step 1: Construct &amp; Sign Payload</a:t>
-            </a:r>
-          </a:p>
-          <a:p>
-            <a:pPr>
-              <a:spcBef>
-                <a:spcPts val="400"/>
-              </a:spcBef>
-              <a:defRPr sz="1100">
-                <a:solidFill>
-                  <a:srgbClr val="D1D5DB"/>
-                </a:solidFill>
-              </a:defRPr>
-            </a:pPr>
-            <a:r>
-              <a:t>- Payload: Timestamp|Component_ID|Action|Tech_ID|Health</a:t>
-            </a:r>
-            <a:br/>
-            <a:r>
-              <a:t>- Station_001 signs using private Ed25519 key</a:t>
-            </a:r>
-            <a:br/>
-            <a:r>
-              <a:t>- Payload and Signature posted to /append endpoint</a:t>
-            </a:r>
-          </a:p>
-          <a:p>
-            <a:pPr>
-              <a:spcBef>
-                <a:spcPts val="1000"/>
-              </a:spcBef>
-              <a:spcAft>
-                <a:spcPts val="600"/>
-              </a:spcAft>
-              <a:defRPr sz="1400" b="1">
-                <a:solidFill>
-                  <a:srgbClr val="14B8A6"/>
-                </a:solidFill>
-              </a:defRPr>
-            </a:pPr>
-            <a:r>
-              <a:t>Step 2: Gateway Verify &amp; Log</a:t>
-            </a:r>
-          </a:p>
-          <a:p>
-            <a:pPr>
-              <a:defRPr sz="1100">
-                <a:solidFill>
-                  <a:srgbClr val="D1D5DB"/>
-                </a:solidFill>
-              </a:defRPr>
-            </a:pPr>
-            <a:r>
-              <a:t>- Gateway checks signature with public key</a:t>
-            </a:r>
-            <a:br/>
-            <a:r>
-              <a:t>- Inserts row into SQLite mro_ledger</a:t>
-            </a:r>
-            <a:br/>
-            <a:r>
-              <a:t>- Recomputes MMR leaf hash and merges peaks</a:t>
-            </a:r>
-          </a:p>
-        </p:txBody>
-      </p:sp>
-      <p:sp>
-        <p:nvSpPr>
-          <p:cNvPr id="6" name="TextBox 5"/>
-          <p:cNvSpPr txBox="1"/>
-          <p:nvPr/>
-        </p:nvSpPr>
-        <p:spPr>
-          <a:xfrm>
-            <a:off x="4754880" y="1188720"/>
-            <a:ext cx="3931920" cy="3474720"/>
-          </a:xfrm>
-          <a:prstGeom prst="rect">
-            <a:avLst/>
-          </a:prstGeom>
-          <a:noFill/>
-        </p:spPr>
-        <p:txBody>
-          <a:bodyPr wrap="square" lIns="0" rIns="0" tIns="0" bIns="0">
-            <a:spAutoFit/>
-          </a:bodyPr>
-          <a:lstStyle/>
-          <a:p>
-            <a:pPr>
-              <a:spcBef>
-                <a:spcPts val="600"/>
-              </a:spcBef>
-              <a:spcAft>
-                <a:spcPts val="600"/>
-              </a:spcAft>
-              <a:defRPr sz="1400" b="1">
-                <a:solidFill>
-                  <a:srgbClr val="14B8A6"/>
-                </a:solidFill>
-              </a:defRPr>
-            </a:pPr>
-            <a:r>
-              <a:t>Step 3: Tampering Simulation</a:t>
-            </a:r>
-          </a:p>
-          <a:p>
-            <a:pPr>
-              <a:spcBef>
-                <a:spcPts val="400"/>
-              </a:spcBef>
-              <a:defRPr sz="1100">
-                <a:solidFill>
-                  <a:srgbClr val="D1D5DB"/>
-                </a:solidFill>
-              </a:defRPr>
-            </a:pPr>
-            <a:r>
-              <a:t>- Intruder updates SQLite table directly</a:t>
-            </a:r>
-            <a:br/>
-            <a:r>
-              <a:t>- Leaf 1 component_id altered to 'TAMPERED-ENG'</a:t>
-            </a:r>
-            <a:br/>
-            <a:r>
-              <a:t>- Node hash &amp; MMR nodes left unchanged</a:t>
-            </a:r>
-          </a:p>
-          <a:p>
-            <a:pPr>
-              <a:spcBef>
-                <a:spcPts val="1000"/>
-              </a:spcBef>
-              <a:spcAft>
-                <a:spcPts val="600"/>
-              </a:spcAft>
-              <a:defRPr sz="1400" b="1">
-                <a:solidFill>
-                  <a:srgbClr val="14B8A6"/>
-                </a:solidFill>
-              </a:defRPr>
-            </a:pPr>
-            <a:r>
-              <a:t>Step 4: Audit Verification Alert</a:t>
-            </a:r>
-          </a:p>
-          <a:p>
-            <a:pPr>
-              <a:defRPr sz="1100">
-                <a:solidFill>
-                  <a:srgbClr val="D1D5DB"/>
-                </a:solidFill>
-              </a:defRPr>
-            </a:pPr>
-            <a:r>
-              <a:t>- Auditor re-computes Leaf 1 hash from raw columns</a:t>
-            </a:r>
-            <a:br/>
-            <a:r>
-              <a:t>- Recomputed hash mismatches stored node_hash</a:t>
-            </a:r>
-            <a:br/>
-            <a:r>
-              <a:t>- System identifies altered leaf index &amp; logs alert</a:t>
-            </a:r>
-          </a:p>
-        </p:txBody>
-      </p:sp>
-    </p:spTree>
-  </p:cSld>
-  <p:clrMapOvr>
-    <a:masterClrMapping/>
-  </p:clrMapOvr>
-</p:sld>
-</file>
-
-<file path=ppt/slides/slide9.xml><?xml version="1.0" encoding="utf-8"?>
-<p:sld xmlns:a="http://schemas.openxmlformats.org/drawingml/2006/main" xmlns:p="http://schemas.openxmlformats.org/presentationml/2006/main" xmlns:r="http://schemas.openxmlformats.org/officeDocument/2006/relationships">
-  <p:cSld>
-    <p:bg>
-      <p:bgPr>
-        <a:solidFill>
-          <a:srgbClr val="0A0A0C"/>
-        </a:solidFill>
-        <a:effectLst/>
-      </p:bgPr>
-    </p:bg>
-    <p:spTree>
-      <p:nvGrpSpPr>
-        <p:cNvPr id="1" name=""/>
-        <p:cNvGrpSpPr/>
-        <p:nvPr/>
-      </p:nvGrpSpPr>
-      <p:grpSpPr/>
-      <p:sp>
-        <p:nvSpPr>
-          <p:cNvPr id="2" name="Rectangle 1"/>
+              <a:t>Audit &amp; Security</a:t>
+            </a:r>
+          </a:p>
+        </p:txBody>
+      </p:sp>
+      <p:sp>
+        <p:nvSpPr>
+          <p:cNvPr id="5" name="Rectangle 4"/>
           <p:cNvSpPr/>
           <p:nvPr/>
         </p:nvSpPr>
         <p:spPr>
           <a:xfrm>
-            <a:off x="0" y="0"/>
-            <a:ext cx="9144000" cy="914400"/>
+            <a:off x="457200" y="1188720"/>
+            <a:ext cx="3931920" cy="3383280"/>
           </a:xfrm>
           <a:prstGeom prst="rect">
             <a:avLst/>
           </a:prstGeom>
           <a:solidFill>
-            <a:srgbClr val="111827"/>
+            <a:srgbClr val="F3F4F6"/>
           </a:solidFill>
-          <a:ln w="19050">
+          <a:ln>
             <a:solidFill>
-              <a:srgbClr val="6366F1"/>
+              <a:srgbClr val="E5E7EB"/>
             </a:solidFill>
           </a:ln>
         </p:spPr>
@@ -5297,205 +4666,190 @@
           </a:fontRef>
         </p:style>
         <p:txBody>
-          <a:bodyPr rtlCol="0" anchor="ctr"/>
-          <a:lstStyle/>
-          <a:p>
-            <a:pPr algn="ctr"/>
-          </a:p>
-        </p:txBody>
-      </p:sp>
-      <p:sp>
-        <p:nvSpPr>
-          <p:cNvPr id="3" name="TextBox 2"/>
-          <p:cNvSpPr txBox="1"/>
-          <p:nvPr/>
-        </p:nvSpPr>
-        <p:spPr>
-          <a:xfrm>
-            <a:off x="457200" y="137160"/>
-            <a:ext cx="5943600" cy="640080"/>
-          </a:xfrm>
-          <a:prstGeom prst="rect">
-            <a:avLst/>
-          </a:prstGeom>
-          <a:noFill/>
-        </p:spPr>
-        <p:txBody>
-          <a:bodyPr wrap="square" lIns="0" rIns="0" tIns="0" bIns="0">
-            <a:spAutoFit/>
-          </a:bodyPr>
-          <a:lstStyle/>
-          <a:p>
-            <a:pPr>
-              <a:defRPr sz="2200" b="1">
-                <a:solidFill>
-                  <a:srgbClr val="FFFFFF"/>
-                </a:solidFill>
-                <a:latin typeface="Arial"/>
+          <a:bodyPr rtlCol="0" anchor="ctr" wrap="square" lIns="137160" tIns="137160"/>
+          <a:lstStyle/>
+          <a:p>
+            <a:pPr algn="ctr">
+              <a:spcAft>
+                <a:spcPts val="800"/>
+              </a:spcAft>
+              <a:defRPr sz="1400" b="1">
+                <a:solidFill>
+                  <a:srgbClr val="1E3A8A"/>
+                </a:solidFill>
               </a:defRPr>
             </a:pPr>
             <a:r>
-              <a:t>Conclusion: SentinelMRO InnoVent-27 Ready</a:t>
-            </a:r>
-          </a:p>
-        </p:txBody>
-      </p:sp>
-      <p:sp>
-        <p:nvSpPr>
-          <p:cNvPr id="4" name="TextBox 3"/>
-          <p:cNvSpPr txBox="1"/>
-          <p:nvPr/>
-        </p:nvSpPr>
-        <p:spPr>
-          <a:xfrm>
-            <a:off x="6400800" y="274320"/>
-            <a:ext cx="2286000" cy="365760"/>
-          </a:xfrm>
-          <a:prstGeom prst="rect">
-            <a:avLst/>
-          </a:prstGeom>
-          <a:noFill/>
-        </p:spPr>
-        <p:txBody>
-          <a:bodyPr wrap="square" lIns="0" rIns="0" tIns="0" bIns="0">
-            <a:spAutoFit/>
-          </a:bodyPr>
-          <a:lstStyle/>
-          <a:p>
-            <a:pPr algn="r">
-              <a:defRPr sz="1000" b="1">
-                <a:solidFill>
-                  <a:srgbClr val="818CF8"/>
-                </a:solidFill>
-                <a:latin typeface="Arial"/>
-              </a:defRPr>
-            </a:pPr>
-            <a:r>
-              <a:t>Competitive Summary</a:t>
-            </a:r>
-          </a:p>
-        </p:txBody>
-      </p:sp>
-      <p:sp>
-        <p:nvSpPr>
-          <p:cNvPr id="5" name="TextBox 4"/>
-          <p:cNvSpPr txBox="1"/>
-          <p:nvPr/>
-        </p:nvSpPr>
-        <p:spPr>
-          <a:xfrm>
-            <a:off x="457200" y="1188720"/>
-            <a:ext cx="8229600" cy="3474720"/>
-          </a:xfrm>
-          <a:prstGeom prst="rect">
-            <a:avLst/>
-          </a:prstGeom>
-          <a:noFill/>
-        </p:spPr>
-        <p:txBody>
-          <a:bodyPr wrap="square" lIns="0" rIns="0" tIns="0" bIns="0">
-            <a:spAutoFit/>
-          </a:bodyPr>
-          <a:lstStyle/>
-          <a:p/>
+              <a:t>Cryptographic Ledger Principles</a:t>
+            </a:r>
+          </a:p>
           <a:p>
             <a:pPr>
+              <a:spcBef>
+                <a:spcPts val="400"/>
+              </a:spcBef>
               <a:spcAft>
                 <a:spcPts val="800"/>
               </a:spcAft>
             </a:pPr>
             <a:r>
-              <a:rPr b="1" sz="1300">
-                <a:solidFill>
-                  <a:srgbClr val="FFFFFF"/>
+              <a:rPr b="1" sz="1200">
+                <a:solidFill>
+                  <a:srgbClr val="1F2937"/>
                 </a:solidFill>
                 <a:latin typeface="Arial"/>
               </a:rPr>
-              <a:t>• Edge-AI Latency: </a:t>
-            </a:r>
-            <a:r>
-              <a:rPr sz="1200">
-                <a:solidFill>
-                  <a:srgbClr val="D1D5DB"/>
+              <a:t>• Ed25519 Gateway Handshake: </a:t>
+            </a:r>
+            <a:r>
+              <a:rPr sz="1100">
+                <a:solidFill>
+                  <a:srgbClr val="4B5563"/>
                 </a:solidFill>
                 <a:latin typeface="Arial"/>
               </a:rPr>
-              <a:t>Model compiled and quantized dynamically, performing edge prediction on CPU in under 3ms.</a:t>
+              <a:t>Every edge submission is signed by the station's private key. Gateway checks signatures in headers using public keys.</a:t>
             </a:r>
           </a:p>
           <a:p>
             <a:pPr>
+              <a:spcBef>
+                <a:spcPts val="400"/>
+              </a:spcBef>
               <a:spcAft>
                 <a:spcPts val="800"/>
               </a:spcAft>
             </a:pPr>
             <a:r>
-              <a:rPr b="1" sz="1300">
-                <a:solidFill>
-                  <a:srgbClr val="FFFFFF"/>
+              <a:rPr b="1" sz="1200">
+                <a:solidFill>
+                  <a:srgbClr val="1F2937"/>
                 </a:solidFill>
                 <a:latin typeface="Arial"/>
               </a:rPr>
-              <a:t>• Federated Optimizers: </a:t>
-            </a:r>
-            <a:r>
-              <a:rPr sz="1200">
-                <a:solidFill>
-                  <a:srgbClr val="D1D5DB"/>
+              <a:t>• Merkle Mountain Range (MMR): </a:t>
+            </a:r>
+            <a:r>
+              <a:rPr sz="1100">
+                <a:solidFill>
+                  <a:srgbClr val="4B5563"/>
                 </a:solidFill>
                 <a:latin typeface="Arial"/>
               </a:rPr>
-              <a:t>FedProx regularizer penalty and LDP noise aggregation fully operational.</a:t>
+              <a:t>Appends nodes to a binary tree in post-order flat indexing. Enables O(log n) inclusion proofs and rapid integrity verification checks.</a:t>
+            </a:r>
+          </a:p>
+        </p:txBody>
+      </p:sp>
+      <p:sp>
+        <p:nvSpPr>
+          <p:cNvPr id="6" name="Rectangle 5"/>
+          <p:cNvSpPr/>
+          <p:nvPr/>
+        </p:nvSpPr>
+        <p:spPr>
+          <a:xfrm>
+            <a:off x="4754880" y="1188720"/>
+            <a:ext cx="3931920" cy="3383280"/>
+          </a:xfrm>
+          <a:prstGeom prst="rect">
+            <a:avLst/>
+          </a:prstGeom>
+          <a:solidFill>
+            <a:srgbClr val="F3F4F6"/>
+          </a:solidFill>
+          <a:ln>
+            <a:solidFill>
+              <a:srgbClr val="E5E7EB"/>
+            </a:solidFill>
+          </a:ln>
+        </p:spPr>
+        <p:style>
+          <a:lnRef idx="1">
+            <a:schemeClr val="accent1"/>
+          </a:lnRef>
+          <a:fillRef idx="3">
+            <a:schemeClr val="accent1"/>
+          </a:fillRef>
+          <a:effectRef idx="2">
+            <a:schemeClr val="accent1"/>
+          </a:effectRef>
+          <a:fontRef idx="minor">
+            <a:schemeClr val="lt1"/>
+          </a:fontRef>
+        </p:style>
+        <p:txBody>
+          <a:bodyPr rtlCol="0" anchor="ctr" wrap="square" lIns="137160" tIns="137160"/>
+          <a:lstStyle/>
+          <a:p>
+            <a:pPr algn="ctr">
+              <a:spcAft>
+                <a:spcPts val="800"/>
+              </a:spcAft>
+              <a:defRPr sz="1400" b="1">
+                <a:solidFill>
+                  <a:srgbClr val="1E3A8A"/>
+                </a:solidFill>
+              </a:defRPr>
+            </a:pPr>
+            <a:r>
+              <a:t>Tamper Backdoor Demonstration</a:t>
             </a:r>
           </a:p>
           <a:p>
             <a:pPr>
+              <a:spcBef>
+                <a:spcPts val="400"/>
+              </a:spcBef>
               <a:spcAft>
                 <a:spcPts val="800"/>
               </a:spcAft>
             </a:pPr>
             <a:r>
-              <a:rPr b="1" sz="1300">
-                <a:solidFill>
-                  <a:srgbClr val="FFFFFF"/>
+              <a:rPr b="1" sz="1200">
+                <a:solidFill>
+                  <a:srgbClr val="1F2937"/>
                 </a:solidFill>
                 <a:latin typeface="Arial"/>
               </a:rPr>
-              <a:t>• Audit Integrity: </a:t>
-            </a:r>
-            <a:r>
-              <a:rPr sz="1200">
-                <a:solidFill>
-                  <a:srgbClr val="D1D5DB"/>
+              <a:t>• Injecting Corrupted Payload: </a:t>
+            </a:r>
+            <a:r>
+              <a:rPr sz="1100">
+                <a:solidFill>
+                  <a:srgbClr val="4B5563"/>
                 </a:solidFill>
                 <a:latin typeface="Arial"/>
               </a:rPr>
-              <a:t>SQLite-backed MMR append, verify, and backdoor tampering functions fully complete.</a:t>
+              <a:t>Updates SQLite columns directly (e.g. component_id='TAMPERED-ENG') but leaves the MMR nodes unchanged.</a:t>
             </a:r>
           </a:p>
           <a:p>
             <a:pPr>
+              <a:spcBef>
+                <a:spcPts val="400"/>
+              </a:spcBef>
               <a:spcAft>
                 <a:spcPts val="800"/>
               </a:spcAft>
             </a:pPr>
             <a:r>
-              <a:rPr b="1" sz="1300">
-                <a:solidFill>
-                  <a:srgbClr val="FFFFFF"/>
+              <a:rPr b="1" sz="1200">
+                <a:solidFill>
+                  <a:srgbClr val="1F2937"/>
                 </a:solidFill>
                 <a:latin typeface="Arial"/>
               </a:rPr>
-              <a:t>• Command Console: </a:t>
-            </a:r>
-            <a:r>
-              <a:rPr sz="1200">
-                <a:solidFill>
-                  <a:srgbClr val="D1D5DB"/>
+              <a:t>• Verification Alert: </a:t>
+            </a:r>
+            <a:r>
+              <a:rPr sz="1100">
+                <a:solidFill>
+                  <a:srgbClr val="4B5563"/>
                 </a:solidFill>
                 <a:latin typeface="Arial"/>
               </a:rPr>
-              <a:t>Next.js 15 dashboard offers high-fidelity visual control room, ready for live presentation.</a:t>
+              <a:t>Recomputing leaf hashes during audits reveals a discrepancy with stored node hashes. The UI validation alarm instantly flashes red.</a:t>
             </a:r>
           </a:p>
         </p:txBody>
@@ -5505,6 +4859,973 @@
   <p:clrMapOvr>
     <a:masterClrMapping/>
   </p:clrMapOvr>
+  <p:transition spd="med">
+    <p:fade/>
+  </p:transition>
+</p:sld>
+</file>
+
+<file path=ppt/slides/slide7.xml><?xml version="1.0" encoding="utf-8"?>
+<p:sld xmlns:a="http://schemas.openxmlformats.org/drawingml/2006/main" xmlns:p="http://schemas.openxmlformats.org/presentationml/2006/main" xmlns:r="http://schemas.openxmlformats.org/officeDocument/2006/relationships">
+  <p:cSld>
+    <p:bg>
+      <p:bgPr>
+        <a:solidFill>
+          <a:srgbClr val="FAFAFA"/>
+        </a:solidFill>
+        <a:effectLst/>
+      </p:bgPr>
+    </p:bg>
+    <p:spTree>
+      <p:nvGrpSpPr>
+        <p:cNvPr id="1" name=""/>
+        <p:cNvGrpSpPr/>
+        <p:nvPr/>
+      </p:nvGrpSpPr>
+      <p:grpSpPr/>
+      <p:sp>
+        <p:nvSpPr>
+          <p:cNvPr id="2" name="Rectangle 1"/>
+          <p:cNvSpPr/>
+          <p:nvPr/>
+        </p:nvSpPr>
+        <p:spPr>
+          <a:xfrm>
+            <a:off x="0" y="0"/>
+            <a:ext cx="9144000" cy="822960"/>
+          </a:xfrm>
+          <a:prstGeom prst="rect">
+            <a:avLst/>
+          </a:prstGeom>
+          <a:solidFill>
+            <a:srgbClr val="F3F4F6"/>
+          </a:solidFill>
+          <a:ln w="12700">
+            <a:solidFill>
+              <a:srgbClr val="E5E7EB"/>
+            </a:solidFill>
+          </a:ln>
+        </p:spPr>
+        <p:style>
+          <a:lnRef idx="1">
+            <a:schemeClr val="accent1"/>
+          </a:lnRef>
+          <a:fillRef idx="3">
+            <a:schemeClr val="accent1"/>
+          </a:fillRef>
+          <a:effectRef idx="2">
+            <a:schemeClr val="accent1"/>
+          </a:effectRef>
+          <a:fontRef idx="minor">
+            <a:schemeClr val="lt1"/>
+          </a:fontRef>
+        </p:style>
+        <p:txBody>
+          <a:bodyPr rtlCol="0" anchor="ctr"/>
+          <a:lstStyle/>
+          <a:p>
+            <a:pPr algn="ctr"/>
+          </a:p>
+        </p:txBody>
+      </p:sp>
+      <p:sp>
+        <p:nvSpPr>
+          <p:cNvPr id="3" name="TextBox 2"/>
+          <p:cNvSpPr txBox="1"/>
+          <p:nvPr/>
+        </p:nvSpPr>
+        <p:spPr>
+          <a:xfrm>
+            <a:off x="457200" y="109728"/>
+            <a:ext cx="5943600" cy="548640"/>
+          </a:xfrm>
+          <a:prstGeom prst="rect">
+            <a:avLst/>
+          </a:prstGeom>
+          <a:noFill/>
+        </p:spPr>
+        <p:txBody>
+          <a:bodyPr wrap="square" lIns="0" rIns="0" tIns="0" bIns="0">
+            <a:spAutoFit/>
+          </a:bodyPr>
+          <a:lstStyle/>
+          <a:p>
+            <a:pPr>
+              <a:defRPr sz="2000" b="1">
+                <a:solidFill>
+                  <a:srgbClr val="1E3A8A"/>
+                </a:solidFill>
+                <a:latin typeface="Arial"/>
+              </a:defRPr>
+            </a:pPr>
+            <a:r>
+              <a:t>Phase 4: Next.js 15 Command Console</a:t>
+            </a:r>
+          </a:p>
+        </p:txBody>
+      </p:sp>
+      <p:sp>
+        <p:nvSpPr>
+          <p:cNvPr id="4" name="TextBox 3"/>
+          <p:cNvSpPr txBox="1"/>
+          <p:nvPr/>
+        </p:nvSpPr>
+        <p:spPr>
+          <a:xfrm>
+            <a:off x="6400800" y="228600"/>
+            <a:ext cx="2286000" cy="365760"/>
+          </a:xfrm>
+          <a:prstGeom prst="rect">
+            <a:avLst/>
+          </a:prstGeom>
+          <a:noFill/>
+        </p:spPr>
+        <p:txBody>
+          <a:bodyPr wrap="square" lIns="0" rIns="0" tIns="0" bIns="0">
+            <a:spAutoFit/>
+          </a:bodyPr>
+          <a:lstStyle/>
+          <a:p>
+            <a:pPr algn="r">
+              <a:defRPr sz="950" b="1">
+                <a:solidFill>
+                  <a:srgbClr val="0D9488"/>
+                </a:solidFill>
+                <a:latin typeface="Arial"/>
+              </a:defRPr>
+            </a:pPr>
+            <a:r>
+              <a:t>User Interface &amp; Control</a:t>
+            </a:r>
+          </a:p>
+        </p:txBody>
+      </p:sp>
+      <p:sp>
+        <p:nvSpPr>
+          <p:cNvPr id="5" name="TextBox 4"/>
+          <p:cNvSpPr txBox="1"/>
+          <p:nvPr/>
+        </p:nvSpPr>
+        <p:spPr>
+          <a:xfrm>
+            <a:off x="457200" y="1188720"/>
+            <a:ext cx="8229600" cy="3383280"/>
+          </a:xfrm>
+          <a:prstGeom prst="rect">
+            <a:avLst/>
+          </a:prstGeom>
+          <a:noFill/>
+        </p:spPr>
+        <p:txBody>
+          <a:bodyPr wrap="square" lIns="0" rIns="0" tIns="0" bIns="0">
+            <a:spAutoFit/>
+          </a:bodyPr>
+          <a:lstStyle/>
+          <a:p/>
+          <a:p>
+            <a:pPr>
+              <a:spcBef>
+                <a:spcPts val="400"/>
+              </a:spcBef>
+              <a:spcAft>
+                <a:spcPts val="800"/>
+              </a:spcAft>
+            </a:pPr>
+            <a:r>
+              <a:rPr b="1" sz="1200">
+                <a:solidFill>
+                  <a:srgbClr val="1F2937"/>
+                </a:solidFill>
+                <a:latin typeface="Arial"/>
+              </a:rPr>
+              <a:t>• Premium Industrial Theme: </a:t>
+            </a:r>
+            <a:r>
+              <a:rPr sz="1100">
+                <a:solidFill>
+                  <a:srgbClr val="4B5563"/>
+                </a:solidFill>
+                <a:latin typeface="Arial"/>
+              </a:rPr>
+              <a:t>Designed on zinc-950/zinc-50 with responsive sidebar navigation, modern typography ( Outfit/Inter), and micro-animations.</a:t>
+            </a:r>
+          </a:p>
+          <a:p>
+            <a:pPr>
+              <a:spcBef>
+                <a:spcPts val="400"/>
+              </a:spcBef>
+              <a:spcAft>
+                <a:spcPts val="800"/>
+              </a:spcAft>
+            </a:pPr>
+            <a:r>
+              <a:rPr b="1" sz="1200">
+                <a:solidFill>
+                  <a:srgbClr val="1F2937"/>
+                </a:solidFill>
+                <a:latin typeface="Arial"/>
+              </a:rPr>
+              <a:t>• Real-time Telemetry curves: </a:t>
+            </a:r>
+            <a:r>
+              <a:rPr sz="1100">
+                <a:solidFill>
+                  <a:srgbClr val="4B5563"/>
+                </a:solidFill>
+                <a:latin typeface="Arial"/>
+              </a:rPr>
+              <a:t>Visualizes TCN RUL outputs alongside core speed temperature and bypass ratio trends using high-frequency Recharts curves.</a:t>
+            </a:r>
+          </a:p>
+          <a:p>
+            <a:pPr>
+              <a:spcBef>
+                <a:spcPts val="400"/>
+              </a:spcBef>
+              <a:spcAft>
+                <a:spcPts val="800"/>
+              </a:spcAft>
+            </a:pPr>
+            <a:r>
+              <a:rPr b="1" sz="1200">
+                <a:solidFill>
+                  <a:srgbClr val="1F2937"/>
+                </a:solidFill>
+                <a:latin typeface="Arial"/>
+              </a:rPr>
+              <a:t>• Auditing Control Console: </a:t>
+            </a:r>
+            <a:r>
+              <a:rPr sz="1100">
+                <a:solidFill>
+                  <a:srgbClr val="4B5563"/>
+                </a:solidFill>
+                <a:latin typeface="Arial"/>
+              </a:rPr>
+              <a:t>Provides buttons to Verify Ecosystem Integrity or Simulate Malicious Database Injection. Alerts flash green on success and red on mismatch.</a:t>
+            </a:r>
+          </a:p>
+        </p:txBody>
+      </p:sp>
+    </p:spTree>
+  </p:cSld>
+  <p:clrMapOvr>
+    <a:masterClrMapping/>
+  </p:clrMapOvr>
+  <p:transition spd="med">
+    <p:fade/>
+  </p:transition>
+</p:sld>
+</file>
+
+<file path=ppt/slides/slide8.xml><?xml version="1.0" encoding="utf-8"?>
+<p:sld xmlns:a="http://schemas.openxmlformats.org/drawingml/2006/main" xmlns:p="http://schemas.openxmlformats.org/presentationml/2006/main" xmlns:r="http://schemas.openxmlformats.org/officeDocument/2006/relationships">
+  <p:cSld>
+    <p:bg>
+      <p:bgPr>
+        <a:solidFill>
+          <a:srgbClr val="FAFAFA"/>
+        </a:solidFill>
+        <a:effectLst/>
+      </p:bgPr>
+    </p:bg>
+    <p:spTree>
+      <p:nvGrpSpPr>
+        <p:cNvPr id="1" name=""/>
+        <p:cNvGrpSpPr/>
+        <p:nvPr/>
+      </p:nvGrpSpPr>
+      <p:grpSpPr/>
+      <p:sp>
+        <p:nvSpPr>
+          <p:cNvPr id="2" name="Rectangle 1"/>
+          <p:cNvSpPr/>
+          <p:nvPr/>
+        </p:nvSpPr>
+        <p:spPr>
+          <a:xfrm>
+            <a:off x="0" y="0"/>
+            <a:ext cx="9144000" cy="822960"/>
+          </a:xfrm>
+          <a:prstGeom prst="rect">
+            <a:avLst/>
+          </a:prstGeom>
+          <a:solidFill>
+            <a:srgbClr val="F3F4F6"/>
+          </a:solidFill>
+          <a:ln w="12700">
+            <a:solidFill>
+              <a:srgbClr val="E5E7EB"/>
+            </a:solidFill>
+          </a:ln>
+        </p:spPr>
+        <p:style>
+          <a:lnRef idx="1">
+            <a:schemeClr val="accent1"/>
+          </a:lnRef>
+          <a:fillRef idx="3">
+            <a:schemeClr val="accent1"/>
+          </a:fillRef>
+          <a:effectRef idx="2">
+            <a:schemeClr val="accent1"/>
+          </a:effectRef>
+          <a:fontRef idx="minor">
+            <a:schemeClr val="lt1"/>
+          </a:fontRef>
+        </p:style>
+        <p:txBody>
+          <a:bodyPr rtlCol="0" anchor="ctr"/>
+          <a:lstStyle/>
+          <a:p>
+            <a:pPr algn="ctr"/>
+          </a:p>
+        </p:txBody>
+      </p:sp>
+      <p:sp>
+        <p:nvSpPr>
+          <p:cNvPr id="3" name="TextBox 2"/>
+          <p:cNvSpPr txBox="1"/>
+          <p:nvPr/>
+        </p:nvSpPr>
+        <p:spPr>
+          <a:xfrm>
+            <a:off x="457200" y="109728"/>
+            <a:ext cx="5943600" cy="548640"/>
+          </a:xfrm>
+          <a:prstGeom prst="rect">
+            <a:avLst/>
+          </a:prstGeom>
+          <a:noFill/>
+        </p:spPr>
+        <p:txBody>
+          <a:bodyPr wrap="square" lIns="0" rIns="0" tIns="0" bIns="0">
+            <a:spAutoFit/>
+          </a:bodyPr>
+          <a:lstStyle/>
+          <a:p>
+            <a:pPr>
+              <a:defRPr sz="2000" b="1">
+                <a:solidFill>
+                  <a:srgbClr val="1E3A8A"/>
+                </a:solidFill>
+                <a:latin typeface="Arial"/>
+              </a:defRPr>
+            </a:pPr>
+            <a:r>
+              <a:t>Worked Trace Example: Maintenance Logging</a:t>
+            </a:r>
+          </a:p>
+        </p:txBody>
+      </p:sp>
+      <p:sp>
+        <p:nvSpPr>
+          <p:cNvPr id="4" name="TextBox 3"/>
+          <p:cNvSpPr txBox="1"/>
+          <p:nvPr/>
+        </p:nvSpPr>
+        <p:spPr>
+          <a:xfrm>
+            <a:off x="6400800" y="228600"/>
+            <a:ext cx="2286000" cy="365760"/>
+          </a:xfrm>
+          <a:prstGeom prst="rect">
+            <a:avLst/>
+          </a:prstGeom>
+          <a:noFill/>
+        </p:spPr>
+        <p:txBody>
+          <a:bodyPr wrap="square" lIns="0" rIns="0" tIns="0" bIns="0">
+            <a:spAutoFit/>
+          </a:bodyPr>
+          <a:lstStyle/>
+          <a:p>
+            <a:pPr algn="r">
+              <a:defRPr sz="950" b="1">
+                <a:solidFill>
+                  <a:srgbClr val="0D9488"/>
+                </a:solidFill>
+                <a:latin typeface="Arial"/>
+              </a:defRPr>
+            </a:pPr>
+            <a:r>
+              <a:t>Ecosystem in Action</a:t>
+            </a:r>
+          </a:p>
+        </p:txBody>
+      </p:sp>
+      <p:sp>
+        <p:nvSpPr>
+          <p:cNvPr id="5" name="Rectangle 4"/>
+          <p:cNvSpPr/>
+          <p:nvPr/>
+        </p:nvSpPr>
+        <p:spPr>
+          <a:xfrm>
+            <a:off x="457200" y="1188720"/>
+            <a:ext cx="3931920" cy="3383280"/>
+          </a:xfrm>
+          <a:prstGeom prst="rect">
+            <a:avLst/>
+          </a:prstGeom>
+          <a:solidFill>
+            <a:srgbClr val="F3F4F6"/>
+          </a:solidFill>
+          <a:ln>
+            <a:solidFill>
+              <a:srgbClr val="E5E7EB"/>
+            </a:solidFill>
+          </a:ln>
+        </p:spPr>
+        <p:style>
+          <a:lnRef idx="1">
+            <a:schemeClr val="accent1"/>
+          </a:lnRef>
+          <a:fillRef idx="3">
+            <a:schemeClr val="accent1"/>
+          </a:fillRef>
+          <a:effectRef idx="2">
+            <a:schemeClr val="accent1"/>
+          </a:effectRef>
+          <a:fontRef idx="minor">
+            <a:schemeClr val="lt1"/>
+          </a:fontRef>
+        </p:style>
+        <p:txBody>
+          <a:bodyPr rtlCol="0" anchor="ctr" wrap="square" lIns="137160" tIns="137160"/>
+          <a:lstStyle/>
+          <a:p>
+            <a:pPr algn="ctr">
+              <a:spcAft>
+                <a:spcPts val="800"/>
+              </a:spcAft>
+              <a:defRPr sz="1400" b="1">
+                <a:solidFill>
+                  <a:srgbClr val="1E3A8A"/>
+                </a:solidFill>
+              </a:defRPr>
+            </a:pPr>
+            <a:r>
+              <a:t>1. Logging &amp; Signing</a:t>
+            </a:r>
+          </a:p>
+          <a:p>
+            <a:pPr>
+              <a:spcBef>
+                <a:spcPts val="400"/>
+              </a:spcBef>
+              <a:spcAft>
+                <a:spcPts val="800"/>
+              </a:spcAft>
+            </a:pPr>
+            <a:r>
+              <a:rPr b="1" sz="1200">
+                <a:solidFill>
+                  <a:srgbClr val="1F2937"/>
+                </a:solidFill>
+                <a:latin typeface="Arial"/>
+              </a:rPr>
+              <a:t>• Generate Payload: </a:t>
+            </a:r>
+            <a:r>
+              <a:rPr sz="1100">
+                <a:solidFill>
+                  <a:srgbClr val="4B5563"/>
+                </a:solidFill>
+                <a:latin typeface="Arial"/>
+              </a:rPr>
+              <a:t>Edge node compiles: Timestamp|Component_ID|Action|Tech_ID|Health.</a:t>
+            </a:r>
+          </a:p>
+          <a:p>
+            <a:pPr>
+              <a:spcBef>
+                <a:spcPts val="400"/>
+              </a:spcBef>
+              <a:spcAft>
+                <a:spcPts val="800"/>
+              </a:spcAft>
+            </a:pPr>
+            <a:r>
+              <a:rPr b="1" sz="1200">
+                <a:solidFill>
+                  <a:srgbClr val="1F2937"/>
+                </a:solidFill>
+                <a:latin typeface="Arial"/>
+              </a:rPr>
+              <a:t>• Ed25519 Signature: </a:t>
+            </a:r>
+            <a:r>
+              <a:rPr sz="1100">
+                <a:solidFill>
+                  <a:srgbClr val="4B5563"/>
+                </a:solidFill>
+                <a:latin typeface="Arial"/>
+              </a:rPr>
+              <a:t>Signs payload using private key. Submitted in header to API gateway.</a:t>
+            </a:r>
+          </a:p>
+          <a:p>
+            <a:pPr>
+              <a:spcBef>
+                <a:spcPts val="400"/>
+              </a:spcBef>
+              <a:spcAft>
+                <a:spcPts val="800"/>
+              </a:spcAft>
+            </a:pPr>
+            <a:r>
+              <a:rPr b="1" sz="1200">
+                <a:solidFill>
+                  <a:srgbClr val="1F2937"/>
+                </a:solidFill>
+                <a:latin typeface="Arial"/>
+              </a:rPr>
+              <a:t>• Merkle Leaf Append: </a:t>
+            </a:r>
+            <a:r>
+              <a:rPr sz="1100">
+                <a:solidFill>
+                  <a:srgbClr val="4B5563"/>
+                </a:solidFill>
+                <a:latin typeface="Arial"/>
+              </a:rPr>
+              <a:t>Gateway verifies signature, writes row, and appends leaf hash: '5f8a0dc4f67c...' to SQLite.</a:t>
+            </a:r>
+          </a:p>
+        </p:txBody>
+      </p:sp>
+      <p:sp>
+        <p:nvSpPr>
+          <p:cNvPr id="6" name="Rectangle 5"/>
+          <p:cNvSpPr/>
+          <p:nvPr/>
+        </p:nvSpPr>
+        <p:spPr>
+          <a:xfrm>
+            <a:off x="4754880" y="1188720"/>
+            <a:ext cx="3931920" cy="3383280"/>
+          </a:xfrm>
+          <a:prstGeom prst="rect">
+            <a:avLst/>
+          </a:prstGeom>
+          <a:solidFill>
+            <a:srgbClr val="F3F4F6"/>
+          </a:solidFill>
+          <a:ln>
+            <a:solidFill>
+              <a:srgbClr val="E5E7EB"/>
+            </a:solidFill>
+          </a:ln>
+        </p:spPr>
+        <p:style>
+          <a:lnRef idx="1">
+            <a:schemeClr val="accent1"/>
+          </a:lnRef>
+          <a:fillRef idx="3">
+            <a:schemeClr val="accent1"/>
+          </a:fillRef>
+          <a:effectRef idx="2">
+            <a:schemeClr val="accent1"/>
+          </a:effectRef>
+          <a:fontRef idx="minor">
+            <a:schemeClr val="lt1"/>
+          </a:fontRef>
+        </p:style>
+        <p:txBody>
+          <a:bodyPr rtlCol="0" anchor="ctr" wrap="square" lIns="137160" tIns="137160"/>
+          <a:lstStyle/>
+          <a:p>
+            <a:pPr algn="ctr">
+              <a:spcAft>
+                <a:spcPts val="800"/>
+              </a:spcAft>
+              <a:defRPr sz="1400" b="1">
+                <a:solidFill>
+                  <a:srgbClr val="1E3A8A"/>
+                </a:solidFill>
+              </a:defRPr>
+            </a:pPr>
+            <a:r>
+              <a:t>2. Tampering &amp; Alerting</a:t>
+            </a:r>
+          </a:p>
+          <a:p>
+            <a:pPr>
+              <a:spcBef>
+                <a:spcPts val="400"/>
+              </a:spcBef>
+              <a:spcAft>
+                <a:spcPts val="800"/>
+              </a:spcAft>
+            </a:pPr>
+            <a:r>
+              <a:rPr b="1" sz="1200">
+                <a:solidFill>
+                  <a:srgbClr val="1F2937"/>
+                </a:solidFill>
+                <a:latin typeface="Arial"/>
+              </a:rPr>
+              <a:t>• Malicious Modification: </a:t>
+            </a:r>
+            <a:r>
+              <a:rPr sz="1100">
+                <a:solidFill>
+                  <a:srgbClr val="4B5563"/>
+                </a:solidFill>
+                <a:latin typeface="Arial"/>
+              </a:rPr>
+              <a:t>Intruder updates SQLite directly (e.g. altering the component_id to 'TAMPERED-ENG').</a:t>
+            </a:r>
+          </a:p>
+          <a:p>
+            <a:pPr>
+              <a:spcBef>
+                <a:spcPts val="400"/>
+              </a:spcBef>
+              <a:spcAft>
+                <a:spcPts val="800"/>
+              </a:spcAft>
+            </a:pPr>
+            <a:r>
+              <a:rPr b="1" sz="1200">
+                <a:solidFill>
+                  <a:srgbClr val="1F2937"/>
+                </a:solidFill>
+                <a:latin typeface="Arial"/>
+              </a:rPr>
+              <a:t>• Hash Discrepancy: </a:t>
+            </a:r>
+            <a:r>
+              <a:rPr sz="1100">
+                <a:solidFill>
+                  <a:srgbClr val="4B5563"/>
+                </a:solidFill>
+                <a:latin typeface="Arial"/>
+              </a:rPr>
+              <a:t>Auditor re-computes Leaf 1 hash, producing '7a11c8...', which mismatches the stored '5f8a0dc4f67c...' value.</a:t>
+            </a:r>
+          </a:p>
+          <a:p>
+            <a:pPr>
+              <a:spcBef>
+                <a:spcPts val="400"/>
+              </a:spcBef>
+              <a:spcAft>
+                <a:spcPts val="800"/>
+              </a:spcAft>
+            </a:pPr>
+            <a:r>
+              <a:rPr b="1" sz="1200">
+                <a:solidFill>
+                  <a:srgbClr val="1F2937"/>
+                </a:solidFill>
+                <a:latin typeface="Arial"/>
+              </a:rPr>
+              <a:t>• Ecosystem Integrity Alarm: </a:t>
+            </a:r>
+            <a:r>
+              <a:rPr sz="1100">
+                <a:solidFill>
+                  <a:srgbClr val="4B5563"/>
+                </a:solidFill>
+                <a:latin typeface="Arial"/>
+              </a:rPr>
+              <a:t>Mismatch invalidates the MMR root. The command console validation indicator flashes red and displays an alert.</a:t>
+            </a:r>
+          </a:p>
+        </p:txBody>
+      </p:sp>
+    </p:spTree>
+  </p:cSld>
+  <p:clrMapOvr>
+    <a:masterClrMapping/>
+  </p:clrMapOvr>
+  <p:transition spd="med">
+    <p:fade/>
+  </p:transition>
+</p:sld>
+</file>
+
+<file path=ppt/slides/slide9.xml><?xml version="1.0" encoding="utf-8"?>
+<p:sld xmlns:a="http://schemas.openxmlformats.org/drawingml/2006/main" xmlns:p="http://schemas.openxmlformats.org/presentationml/2006/main" xmlns:r="http://schemas.openxmlformats.org/officeDocument/2006/relationships">
+  <p:cSld>
+    <p:bg>
+      <p:bgPr>
+        <a:solidFill>
+          <a:srgbClr val="FAFAFA"/>
+        </a:solidFill>
+        <a:effectLst/>
+      </p:bgPr>
+    </p:bg>
+    <p:spTree>
+      <p:nvGrpSpPr>
+        <p:cNvPr id="1" name=""/>
+        <p:cNvGrpSpPr/>
+        <p:nvPr/>
+      </p:nvGrpSpPr>
+      <p:grpSpPr/>
+      <p:sp>
+        <p:nvSpPr>
+          <p:cNvPr id="2" name="Rectangle 1"/>
+          <p:cNvSpPr/>
+          <p:nvPr/>
+        </p:nvSpPr>
+        <p:spPr>
+          <a:xfrm>
+            <a:off x="0" y="0"/>
+            <a:ext cx="9144000" cy="822960"/>
+          </a:xfrm>
+          <a:prstGeom prst="rect">
+            <a:avLst/>
+          </a:prstGeom>
+          <a:solidFill>
+            <a:srgbClr val="F3F4F6"/>
+          </a:solidFill>
+          <a:ln w="12700">
+            <a:solidFill>
+              <a:srgbClr val="E5E7EB"/>
+            </a:solidFill>
+          </a:ln>
+        </p:spPr>
+        <p:style>
+          <a:lnRef idx="1">
+            <a:schemeClr val="accent1"/>
+          </a:lnRef>
+          <a:fillRef idx="3">
+            <a:schemeClr val="accent1"/>
+          </a:fillRef>
+          <a:effectRef idx="2">
+            <a:schemeClr val="accent1"/>
+          </a:effectRef>
+          <a:fontRef idx="minor">
+            <a:schemeClr val="lt1"/>
+          </a:fontRef>
+        </p:style>
+        <p:txBody>
+          <a:bodyPr rtlCol="0" anchor="ctr"/>
+          <a:lstStyle/>
+          <a:p>
+            <a:pPr algn="ctr"/>
+          </a:p>
+        </p:txBody>
+      </p:sp>
+      <p:sp>
+        <p:nvSpPr>
+          <p:cNvPr id="3" name="TextBox 2"/>
+          <p:cNvSpPr txBox="1"/>
+          <p:nvPr/>
+        </p:nvSpPr>
+        <p:spPr>
+          <a:xfrm>
+            <a:off x="457200" y="109728"/>
+            <a:ext cx="5943600" cy="548640"/>
+          </a:xfrm>
+          <a:prstGeom prst="rect">
+            <a:avLst/>
+          </a:prstGeom>
+          <a:noFill/>
+        </p:spPr>
+        <p:txBody>
+          <a:bodyPr wrap="square" lIns="0" rIns="0" tIns="0" bIns="0">
+            <a:spAutoFit/>
+          </a:bodyPr>
+          <a:lstStyle/>
+          <a:p>
+            <a:pPr>
+              <a:defRPr sz="2000" b="1">
+                <a:solidFill>
+                  <a:srgbClr val="1E3A8A"/>
+                </a:solidFill>
+                <a:latin typeface="Arial"/>
+              </a:defRPr>
+            </a:pPr>
+            <a:r>
+              <a:t>Conclusion: SentinelMRO InnoVent-27 Ready</a:t>
+            </a:r>
+          </a:p>
+        </p:txBody>
+      </p:sp>
+      <p:sp>
+        <p:nvSpPr>
+          <p:cNvPr id="4" name="TextBox 3"/>
+          <p:cNvSpPr txBox="1"/>
+          <p:nvPr/>
+        </p:nvSpPr>
+        <p:spPr>
+          <a:xfrm>
+            <a:off x="6400800" y="228600"/>
+            <a:ext cx="2286000" cy="365760"/>
+          </a:xfrm>
+          <a:prstGeom prst="rect">
+            <a:avLst/>
+          </a:prstGeom>
+          <a:noFill/>
+        </p:spPr>
+        <p:txBody>
+          <a:bodyPr wrap="square" lIns="0" rIns="0" tIns="0" bIns="0">
+            <a:spAutoFit/>
+          </a:bodyPr>
+          <a:lstStyle/>
+          <a:p>
+            <a:pPr algn="r">
+              <a:defRPr sz="950" b="1">
+                <a:solidFill>
+                  <a:srgbClr val="0D9488"/>
+                </a:solidFill>
+                <a:latin typeface="Arial"/>
+              </a:defRPr>
+            </a:pPr>
+            <a:r>
+              <a:t>Competitive Summary</a:t>
+            </a:r>
+          </a:p>
+        </p:txBody>
+      </p:sp>
+      <p:sp>
+        <p:nvSpPr>
+          <p:cNvPr id="5" name="TextBox 4"/>
+          <p:cNvSpPr txBox="1"/>
+          <p:nvPr/>
+        </p:nvSpPr>
+        <p:spPr>
+          <a:xfrm>
+            <a:off x="457200" y="1188720"/>
+            <a:ext cx="8229600" cy="3383280"/>
+          </a:xfrm>
+          <a:prstGeom prst="rect">
+            <a:avLst/>
+          </a:prstGeom>
+          <a:noFill/>
+        </p:spPr>
+        <p:txBody>
+          <a:bodyPr wrap="square" lIns="0" rIns="0" tIns="0" bIns="0">
+            <a:spAutoFit/>
+          </a:bodyPr>
+          <a:lstStyle/>
+          <a:p/>
+          <a:p>
+            <a:pPr>
+              <a:spcBef>
+                <a:spcPts val="400"/>
+              </a:spcBef>
+              <a:spcAft>
+                <a:spcPts val="800"/>
+              </a:spcAft>
+            </a:pPr>
+            <a:r>
+              <a:rPr b="1" sz="1200">
+                <a:solidFill>
+                  <a:srgbClr val="1F2937"/>
+                </a:solidFill>
+                <a:latin typeface="Arial"/>
+              </a:rPr>
+              <a:t>• Edge AI Latency: </a:t>
+            </a:r>
+            <a:r>
+              <a:rPr sz="1100">
+                <a:solidFill>
+                  <a:srgbClr val="4B5563"/>
+                </a:solidFill>
+                <a:latin typeface="Arial"/>
+              </a:rPr>
+              <a:t>Model compiled and quantized dynamically, performing edge prediction on CPU in under 3ms.</a:t>
+            </a:r>
+          </a:p>
+          <a:p>
+            <a:pPr>
+              <a:spcBef>
+                <a:spcPts val="400"/>
+              </a:spcBef>
+              <a:spcAft>
+                <a:spcPts val="800"/>
+              </a:spcAft>
+            </a:pPr>
+            <a:r>
+              <a:rPr b="1" sz="1200">
+                <a:solidFill>
+                  <a:srgbClr val="1F2937"/>
+                </a:solidFill>
+                <a:latin typeface="Arial"/>
+              </a:rPr>
+              <a:t>• Collaborative FedProx: </a:t>
+            </a:r>
+            <a:r>
+              <a:rPr sz="1100">
+                <a:solidFill>
+                  <a:srgbClr val="4B5563"/>
+                </a:solidFill>
+                <a:latin typeface="Arial"/>
+              </a:rPr>
+              <a:t>Federated loop stabilizes updates under non-IID conditions while LDP noise aggregation secures gradients.</a:t>
+            </a:r>
+          </a:p>
+          <a:p>
+            <a:pPr>
+              <a:spcBef>
+                <a:spcPts val="400"/>
+              </a:spcBef>
+              <a:spcAft>
+                <a:spcPts val="800"/>
+              </a:spcAft>
+            </a:pPr>
+            <a:r>
+              <a:rPr b="1" sz="1200">
+                <a:solidFill>
+                  <a:srgbClr val="1F2937"/>
+                </a:solidFill>
+                <a:latin typeface="Arial"/>
+              </a:rPr>
+              <a:t>• Cryptographic Trust: </a:t>
+            </a:r>
+            <a:r>
+              <a:rPr sz="1100">
+                <a:solidFill>
+                  <a:srgbClr val="4B5563"/>
+                </a:solidFill>
+                <a:latin typeface="Arial"/>
+              </a:rPr>
+              <a:t>SQLite-backed MMR append, verify, and backdoor tampering functions fully complete.</a:t>
+            </a:r>
+          </a:p>
+          <a:p>
+            <a:pPr>
+              <a:spcBef>
+                <a:spcPts val="400"/>
+              </a:spcBef>
+              <a:spcAft>
+                <a:spcPts val="800"/>
+              </a:spcAft>
+            </a:pPr>
+            <a:r>
+              <a:rPr b="1" sz="1200">
+                <a:solidFill>
+                  <a:srgbClr val="1F2937"/>
+                </a:solidFill>
+                <a:latin typeface="Arial"/>
+              </a:rPr>
+              <a:t>• Next.js 15 command console: </a:t>
+            </a:r>
+            <a:r>
+              <a:rPr sz="1100">
+                <a:solidFill>
+                  <a:srgbClr val="4B5563"/>
+                </a:solidFill>
+                <a:latin typeface="Arial"/>
+              </a:rPr>
+              <a:t>Command console provides high-fidelity, real-time visual control room ready for live demonstration.</a:t>
+            </a:r>
+          </a:p>
+        </p:txBody>
+      </p:sp>
+    </p:spTree>
+  </p:cSld>
+  <p:clrMapOvr>
+    <a:masterClrMapping/>
+  </p:clrMapOvr>
+  <p:transition spd="med">
+    <p:fade/>
+  </p:transition>
 </p:sld>
 </file>
 

</xml_diff>